<commit_message>
Demo fixes: dbo.spt_values > GENERATE_SERIES()
</commit_message>
<xml_diff>
--- a/SQL_Server_Performance_Optimization.pptx
+++ b/SQL_Server_Performance_Optimization.pptx
@@ -5,52 +5,52 @@
     <p:sldMasterId id="2147483648" r:id="rId1"/>
   </p:sldMasterIdLst>
   <p:sldIdLst>
-    <p:sldId id="256" r:id="rId7"/>
-    <p:sldId id="257" r:id="rId8"/>
-    <p:sldId id="258" r:id="rId9"/>
-    <p:sldId id="259" r:id="rId10"/>
-    <p:sldId id="260" r:id="rId11"/>
-    <p:sldId id="261" r:id="rId12"/>
-    <p:sldId id="262" r:id="rId13"/>
-    <p:sldId id="263" r:id="rId14"/>
-    <p:sldId id="264" r:id="rId15"/>
-    <p:sldId id="265" r:id="rId16"/>
-    <p:sldId id="266" r:id="rId17"/>
-    <p:sldId id="267" r:id="rId18"/>
-    <p:sldId id="268" r:id="rId19"/>
-    <p:sldId id="269" r:id="rId20"/>
-    <p:sldId id="270" r:id="rId21"/>
-    <p:sldId id="271" r:id="rId22"/>
-    <p:sldId id="272" r:id="rId23"/>
-    <p:sldId id="273" r:id="rId24"/>
-    <p:sldId id="274" r:id="rId25"/>
-    <p:sldId id="275" r:id="rId26"/>
-    <p:sldId id="276" r:id="rId27"/>
-    <p:sldId id="277" r:id="rId28"/>
-    <p:sldId id="278" r:id="rId29"/>
-    <p:sldId id="279" r:id="rId30"/>
-    <p:sldId id="280" r:id="rId31"/>
-    <p:sldId id="281" r:id="rId32"/>
-    <p:sldId id="282" r:id="rId33"/>
-    <p:sldId id="283" r:id="rId34"/>
-    <p:sldId id="284" r:id="rId35"/>
-    <p:sldId id="285" r:id="rId36"/>
-    <p:sldId id="286" r:id="rId37"/>
-    <p:sldId id="287" r:id="rId38"/>
-    <p:sldId id="288" r:id="rId39"/>
-    <p:sldId id="289" r:id="rId40"/>
-    <p:sldId id="290" r:id="rId41"/>
-    <p:sldId id="291" r:id="rId42"/>
-    <p:sldId id="292" r:id="rId43"/>
-    <p:sldId id="293" r:id="rId44"/>
-    <p:sldId id="294" r:id="rId45"/>
-    <p:sldId id="295" r:id="rId46"/>
-    <p:sldId id="296" r:id="rId47"/>
-    <p:sldId id="297" r:id="rId48"/>
-    <p:sldId id="298" r:id="rId49"/>
-    <p:sldId id="299" r:id="rId50"/>
-    <p:sldId id="300" r:id="rId51"/>
-    <p:sldId id="301" r:id="rId52"/>
+    <p:sldId id="256" r:id="rId2"/>
+    <p:sldId id="257" r:id="rId3"/>
+    <p:sldId id="258" r:id="rId4"/>
+    <p:sldId id="259" r:id="rId5"/>
+    <p:sldId id="260" r:id="rId6"/>
+    <p:sldId id="261" r:id="rId7"/>
+    <p:sldId id="262" r:id="rId8"/>
+    <p:sldId id="263" r:id="rId9"/>
+    <p:sldId id="264" r:id="rId10"/>
+    <p:sldId id="265" r:id="rId11"/>
+    <p:sldId id="266" r:id="rId12"/>
+    <p:sldId id="267" r:id="rId13"/>
+    <p:sldId id="268" r:id="rId14"/>
+    <p:sldId id="269" r:id="rId15"/>
+    <p:sldId id="270" r:id="rId16"/>
+    <p:sldId id="271" r:id="rId17"/>
+    <p:sldId id="272" r:id="rId18"/>
+    <p:sldId id="273" r:id="rId19"/>
+    <p:sldId id="274" r:id="rId20"/>
+    <p:sldId id="275" r:id="rId21"/>
+    <p:sldId id="276" r:id="rId22"/>
+    <p:sldId id="277" r:id="rId23"/>
+    <p:sldId id="278" r:id="rId24"/>
+    <p:sldId id="279" r:id="rId25"/>
+    <p:sldId id="280" r:id="rId26"/>
+    <p:sldId id="281" r:id="rId27"/>
+    <p:sldId id="282" r:id="rId28"/>
+    <p:sldId id="283" r:id="rId29"/>
+    <p:sldId id="284" r:id="rId30"/>
+    <p:sldId id="285" r:id="rId31"/>
+    <p:sldId id="286" r:id="rId32"/>
+    <p:sldId id="287" r:id="rId33"/>
+    <p:sldId id="288" r:id="rId34"/>
+    <p:sldId id="289" r:id="rId35"/>
+    <p:sldId id="290" r:id="rId36"/>
+    <p:sldId id="291" r:id="rId37"/>
+    <p:sldId id="292" r:id="rId38"/>
+    <p:sldId id="293" r:id="rId39"/>
+    <p:sldId id="294" r:id="rId40"/>
+    <p:sldId id="295" r:id="rId41"/>
+    <p:sldId id="296" r:id="rId42"/>
+    <p:sldId id="297" r:id="rId43"/>
+    <p:sldId id="298" r:id="rId44"/>
+    <p:sldId id="299" r:id="rId45"/>
+    <p:sldId id="300" r:id="rId46"/>
+    <p:sldId id="301" r:id="rId47"/>
   </p:sldIdLst>
   <p:sldSz cx="9144000" cy="6858000" type="screen4x3"/>
   <p:notesSz cx="6858000" cy="9144000"/>
@@ -149,6 +149,22 @@
       </a:defRPr>
     </a:lvl9pPr>
   </p:defaultTextStyle>
+  <p:extLst>
+    <p:ext uri="{EFAFB233-063F-42B5-8137-9DF3F51BA10A}">
+      <p15:sldGuideLst xmlns:p15="http://schemas.microsoft.com/office/powerpoint/2012/main">
+        <p15:guide id="1" orient="horz" pos="2160">
+          <p15:clr>
+            <a:srgbClr val="A4A3A4"/>
+          </p15:clr>
+        </p15:guide>
+        <p15:guide id="2" pos="2880">
+          <p15:clr>
+            <a:srgbClr val="A4A3A4"/>
+          </p15:clr>
+        </p15:guide>
+      </p15:sldGuideLst>
+    </p:ext>
+  </p:extLst>
 </p:presentation>
 </file>
 
@@ -190,10 +206,9 @@
           <a:lstStyle/>
           <a:p>
             <a:r>
-              <a:rPr lang="en-US" smtClean="0"/>
+              <a:rPr lang="en-US"/>
               <a:t>Click to edit Master title style</a:t>
             </a:r>
-            <a:endParaRPr lang="en-US"/>
           </a:p>
         </p:txBody>
       </p:sp>
@@ -309,10 +324,9 @@
           </a:lstStyle>
           <a:p>
             <a:r>
-              <a:rPr lang="en-US" smtClean="0"/>
+              <a:rPr lang="en-US"/>
               <a:t>Click to edit Master subtitle style</a:t>
             </a:r>
-            <a:endParaRPr lang="en-US"/>
           </a:p>
         </p:txBody>
       </p:sp>
@@ -333,7 +347,7 @@
           <a:p>
             <a:fld id="{5BCAD085-E8A6-8845-BD4E-CB4CCA059FC4}" type="datetimeFigureOut">
               <a:rPr lang="en-US" smtClean="0"/>
-              <a:t>1/27/13</a:t>
+              <a:t>9/3/2026</a:t>
             </a:fld>
             <a:endParaRPr lang="en-US"/>
           </a:p>
@@ -427,10 +441,9 @@
           <a:lstStyle/>
           <a:p>
             <a:r>
-              <a:rPr lang="en-US" smtClean="0"/>
+              <a:rPr lang="en-US"/>
               <a:t>Click to edit Master title style</a:t>
             </a:r>
-            <a:endParaRPr lang="en-US"/>
           </a:p>
         </p:txBody>
       </p:sp>
@@ -451,38 +464,37 @@
           <a:p>
             <a:pPr lvl="0"/>
             <a:r>
-              <a:rPr lang="en-US" smtClean="0"/>
+              <a:rPr lang="en-US"/>
               <a:t>Click to edit Master text styles</a:t>
             </a:r>
           </a:p>
           <a:p>
             <a:pPr lvl="1"/>
             <a:r>
-              <a:rPr lang="en-US" smtClean="0"/>
+              <a:rPr lang="en-US"/>
               <a:t>Second level</a:t>
             </a:r>
           </a:p>
           <a:p>
             <a:pPr lvl="2"/>
             <a:r>
-              <a:rPr lang="en-US" smtClean="0"/>
+              <a:rPr lang="en-US"/>
               <a:t>Third level</a:t>
             </a:r>
           </a:p>
           <a:p>
             <a:pPr lvl="3"/>
             <a:r>
-              <a:rPr lang="en-US" smtClean="0"/>
+              <a:rPr lang="en-US"/>
               <a:t>Fourth level</a:t>
             </a:r>
           </a:p>
           <a:p>
             <a:pPr lvl="4"/>
             <a:r>
-              <a:rPr lang="en-US" smtClean="0"/>
+              <a:rPr lang="en-US"/>
               <a:t>Fifth level</a:t>
             </a:r>
-            <a:endParaRPr lang="en-US"/>
           </a:p>
         </p:txBody>
       </p:sp>
@@ -503,7 +515,7 @@
           <a:p>
             <a:fld id="{5BCAD085-E8A6-8845-BD4E-CB4CCA059FC4}" type="datetimeFigureOut">
               <a:rPr lang="en-US" smtClean="0"/>
-              <a:t>1/27/13</a:t>
+              <a:t>9/3/2026</a:t>
             </a:fld>
             <a:endParaRPr lang="en-US"/>
           </a:p>
@@ -602,10 +614,9 @@
           <a:lstStyle/>
           <a:p>
             <a:r>
-              <a:rPr lang="en-US" smtClean="0"/>
+              <a:rPr lang="en-US"/>
               <a:t>Click to edit Master title style</a:t>
             </a:r>
-            <a:endParaRPr lang="en-US"/>
           </a:p>
         </p:txBody>
       </p:sp>
@@ -631,38 +642,37 @@
           <a:p>
             <a:pPr lvl="0"/>
             <a:r>
-              <a:rPr lang="en-US" smtClean="0"/>
+              <a:rPr lang="en-US"/>
               <a:t>Click to edit Master text styles</a:t>
             </a:r>
           </a:p>
           <a:p>
             <a:pPr lvl="1"/>
             <a:r>
-              <a:rPr lang="en-US" smtClean="0"/>
+              <a:rPr lang="en-US"/>
               <a:t>Second level</a:t>
             </a:r>
           </a:p>
           <a:p>
             <a:pPr lvl="2"/>
             <a:r>
-              <a:rPr lang="en-US" smtClean="0"/>
+              <a:rPr lang="en-US"/>
               <a:t>Third level</a:t>
             </a:r>
           </a:p>
           <a:p>
             <a:pPr lvl="3"/>
             <a:r>
-              <a:rPr lang="en-US" smtClean="0"/>
+              <a:rPr lang="en-US"/>
               <a:t>Fourth level</a:t>
             </a:r>
           </a:p>
           <a:p>
             <a:pPr lvl="4"/>
             <a:r>
-              <a:rPr lang="en-US" smtClean="0"/>
+              <a:rPr lang="en-US"/>
               <a:t>Fifth level</a:t>
             </a:r>
-            <a:endParaRPr lang="en-US"/>
           </a:p>
         </p:txBody>
       </p:sp>
@@ -683,7 +693,7 @@
           <a:p>
             <a:fld id="{5BCAD085-E8A6-8845-BD4E-CB4CCA059FC4}" type="datetimeFigureOut">
               <a:rPr lang="en-US" smtClean="0"/>
-              <a:t>1/27/13</a:t>
+              <a:t>9/3/2026</a:t>
             </a:fld>
             <a:endParaRPr lang="en-US"/>
           </a:p>
@@ -777,10 +787,9 @@
           <a:lstStyle/>
           <a:p>
             <a:r>
-              <a:rPr lang="en-US" smtClean="0"/>
+              <a:rPr lang="en-US"/>
               <a:t>Click to edit Master title style</a:t>
             </a:r>
-            <a:endParaRPr lang="en-US"/>
           </a:p>
         </p:txBody>
       </p:sp>
@@ -801,38 +810,37 @@
           <a:p>
             <a:pPr lvl="0"/>
             <a:r>
-              <a:rPr lang="en-US" smtClean="0"/>
+              <a:rPr lang="en-US"/>
               <a:t>Click to edit Master text styles</a:t>
             </a:r>
           </a:p>
           <a:p>
             <a:pPr lvl="1"/>
             <a:r>
-              <a:rPr lang="en-US" smtClean="0"/>
+              <a:rPr lang="en-US"/>
               <a:t>Second level</a:t>
             </a:r>
           </a:p>
           <a:p>
             <a:pPr lvl="2"/>
             <a:r>
-              <a:rPr lang="en-US" smtClean="0"/>
+              <a:rPr lang="en-US"/>
               <a:t>Third level</a:t>
             </a:r>
           </a:p>
           <a:p>
             <a:pPr lvl="3"/>
             <a:r>
-              <a:rPr lang="en-US" smtClean="0"/>
+              <a:rPr lang="en-US"/>
               <a:t>Fourth level</a:t>
             </a:r>
           </a:p>
           <a:p>
             <a:pPr lvl="4"/>
             <a:r>
-              <a:rPr lang="en-US" smtClean="0"/>
+              <a:rPr lang="en-US"/>
               <a:t>Fifth level</a:t>
             </a:r>
-            <a:endParaRPr lang="en-US"/>
           </a:p>
         </p:txBody>
       </p:sp>
@@ -853,7 +861,7 @@
           <a:p>
             <a:fld id="{5BCAD085-E8A6-8845-BD4E-CB4CCA059FC4}" type="datetimeFigureOut">
               <a:rPr lang="en-US" smtClean="0"/>
-              <a:t>1/27/13</a:t>
+              <a:t>9/3/2026</a:t>
             </a:fld>
             <a:endParaRPr lang="en-US"/>
           </a:p>
@@ -956,10 +964,9 @@
           </a:lstStyle>
           <a:p>
             <a:r>
-              <a:rPr lang="en-US" smtClean="0"/>
+              <a:rPr lang="en-US"/>
               <a:t>Click to edit Master title style</a:t>
             </a:r>
-            <a:endParaRPr lang="en-US"/>
           </a:p>
         </p:txBody>
       </p:sp>
@@ -1076,7 +1083,7 @@
           <a:p>
             <a:pPr lvl="0"/>
             <a:r>
-              <a:rPr lang="en-US" smtClean="0"/>
+              <a:rPr lang="en-US"/>
               <a:t>Click to edit Master text styles</a:t>
             </a:r>
           </a:p>
@@ -1099,7 +1106,7 @@
           <a:p>
             <a:fld id="{5BCAD085-E8A6-8845-BD4E-CB4CCA059FC4}" type="datetimeFigureOut">
               <a:rPr lang="en-US" smtClean="0"/>
-              <a:t>1/27/13</a:t>
+              <a:t>9/3/2026</a:t>
             </a:fld>
             <a:endParaRPr lang="en-US"/>
           </a:p>
@@ -1193,10 +1200,9 @@
           <a:lstStyle/>
           <a:p>
             <a:r>
-              <a:rPr lang="en-US" smtClean="0"/>
+              <a:rPr lang="en-US"/>
               <a:t>Click to edit Master title style</a:t>
             </a:r>
-            <a:endParaRPr lang="en-US"/>
           </a:p>
         </p:txBody>
       </p:sp>
@@ -1250,38 +1256,37 @@
           <a:p>
             <a:pPr lvl="0"/>
             <a:r>
-              <a:rPr lang="en-US" smtClean="0"/>
+              <a:rPr lang="en-US"/>
               <a:t>Click to edit Master text styles</a:t>
             </a:r>
           </a:p>
           <a:p>
             <a:pPr lvl="1"/>
             <a:r>
-              <a:rPr lang="en-US" smtClean="0"/>
+              <a:rPr lang="en-US"/>
               <a:t>Second level</a:t>
             </a:r>
           </a:p>
           <a:p>
             <a:pPr lvl="2"/>
             <a:r>
-              <a:rPr lang="en-US" smtClean="0"/>
+              <a:rPr lang="en-US"/>
               <a:t>Third level</a:t>
             </a:r>
           </a:p>
           <a:p>
             <a:pPr lvl="3"/>
             <a:r>
-              <a:rPr lang="en-US" smtClean="0"/>
+              <a:rPr lang="en-US"/>
               <a:t>Fourth level</a:t>
             </a:r>
           </a:p>
           <a:p>
             <a:pPr lvl="4"/>
             <a:r>
-              <a:rPr lang="en-US" smtClean="0"/>
+              <a:rPr lang="en-US"/>
               <a:t>Fifth level</a:t>
             </a:r>
-            <a:endParaRPr lang="en-US"/>
           </a:p>
         </p:txBody>
       </p:sp>
@@ -1335,38 +1340,37 @@
           <a:p>
             <a:pPr lvl="0"/>
             <a:r>
-              <a:rPr lang="en-US" smtClean="0"/>
+              <a:rPr lang="en-US"/>
               <a:t>Click to edit Master text styles</a:t>
             </a:r>
           </a:p>
           <a:p>
             <a:pPr lvl="1"/>
             <a:r>
-              <a:rPr lang="en-US" smtClean="0"/>
+              <a:rPr lang="en-US"/>
               <a:t>Second level</a:t>
             </a:r>
           </a:p>
           <a:p>
             <a:pPr lvl="2"/>
             <a:r>
-              <a:rPr lang="en-US" smtClean="0"/>
+              <a:rPr lang="en-US"/>
               <a:t>Third level</a:t>
             </a:r>
           </a:p>
           <a:p>
             <a:pPr lvl="3"/>
             <a:r>
-              <a:rPr lang="en-US" smtClean="0"/>
+              <a:rPr lang="en-US"/>
               <a:t>Fourth level</a:t>
             </a:r>
           </a:p>
           <a:p>
             <a:pPr lvl="4"/>
             <a:r>
-              <a:rPr lang="en-US" smtClean="0"/>
+              <a:rPr lang="en-US"/>
               <a:t>Fifth level</a:t>
             </a:r>
-            <a:endParaRPr lang="en-US"/>
           </a:p>
         </p:txBody>
       </p:sp>
@@ -1387,7 +1391,7 @@
           <a:p>
             <a:fld id="{5BCAD085-E8A6-8845-BD4E-CB4CCA059FC4}" type="datetimeFigureOut">
               <a:rPr lang="en-US" smtClean="0"/>
-              <a:t>1/27/13</a:t>
+              <a:t>9/3/2026</a:t>
             </a:fld>
             <a:endParaRPr lang="en-US"/>
           </a:p>
@@ -1485,10 +1489,9 @@
           </a:lstStyle>
           <a:p>
             <a:r>
-              <a:rPr lang="en-US" smtClean="0"/>
+              <a:rPr lang="en-US"/>
               <a:t>Click to edit Master title style</a:t>
             </a:r>
-            <a:endParaRPr lang="en-US"/>
           </a:p>
         </p:txBody>
       </p:sp>
@@ -1551,7 +1554,7 @@
           <a:p>
             <a:pPr lvl="0"/>
             <a:r>
-              <a:rPr lang="en-US" smtClean="0"/>
+              <a:rPr lang="en-US"/>
               <a:t>Click to edit Master text styles</a:t>
             </a:r>
           </a:p>
@@ -1607,38 +1610,37 @@
           <a:p>
             <a:pPr lvl="0"/>
             <a:r>
-              <a:rPr lang="en-US" smtClean="0"/>
+              <a:rPr lang="en-US"/>
               <a:t>Click to edit Master text styles</a:t>
             </a:r>
           </a:p>
           <a:p>
             <a:pPr lvl="1"/>
             <a:r>
-              <a:rPr lang="en-US" smtClean="0"/>
+              <a:rPr lang="en-US"/>
               <a:t>Second level</a:t>
             </a:r>
           </a:p>
           <a:p>
             <a:pPr lvl="2"/>
             <a:r>
-              <a:rPr lang="en-US" smtClean="0"/>
+              <a:rPr lang="en-US"/>
               <a:t>Third level</a:t>
             </a:r>
           </a:p>
           <a:p>
             <a:pPr lvl="3"/>
             <a:r>
-              <a:rPr lang="en-US" smtClean="0"/>
+              <a:rPr lang="en-US"/>
               <a:t>Fourth level</a:t>
             </a:r>
           </a:p>
           <a:p>
             <a:pPr lvl="4"/>
             <a:r>
-              <a:rPr lang="en-US" smtClean="0"/>
+              <a:rPr lang="en-US"/>
               <a:t>Fifth level</a:t>
             </a:r>
-            <a:endParaRPr lang="en-US"/>
           </a:p>
         </p:txBody>
       </p:sp>
@@ -1701,7 +1703,7 @@
           <a:p>
             <a:pPr lvl="0"/>
             <a:r>
-              <a:rPr lang="en-US" smtClean="0"/>
+              <a:rPr lang="en-US"/>
               <a:t>Click to edit Master text styles</a:t>
             </a:r>
           </a:p>
@@ -1757,38 +1759,37 @@
           <a:p>
             <a:pPr lvl="0"/>
             <a:r>
-              <a:rPr lang="en-US" smtClean="0"/>
+              <a:rPr lang="en-US"/>
               <a:t>Click to edit Master text styles</a:t>
             </a:r>
           </a:p>
           <a:p>
             <a:pPr lvl="1"/>
             <a:r>
-              <a:rPr lang="en-US" smtClean="0"/>
+              <a:rPr lang="en-US"/>
               <a:t>Second level</a:t>
             </a:r>
           </a:p>
           <a:p>
             <a:pPr lvl="2"/>
             <a:r>
-              <a:rPr lang="en-US" smtClean="0"/>
+              <a:rPr lang="en-US"/>
               <a:t>Third level</a:t>
             </a:r>
           </a:p>
           <a:p>
             <a:pPr lvl="3"/>
             <a:r>
-              <a:rPr lang="en-US" smtClean="0"/>
+              <a:rPr lang="en-US"/>
               <a:t>Fourth level</a:t>
             </a:r>
           </a:p>
           <a:p>
             <a:pPr lvl="4"/>
             <a:r>
-              <a:rPr lang="en-US" smtClean="0"/>
+              <a:rPr lang="en-US"/>
               <a:t>Fifth level</a:t>
             </a:r>
-            <a:endParaRPr lang="en-US"/>
           </a:p>
         </p:txBody>
       </p:sp>
@@ -1809,7 +1810,7 @@
           <a:p>
             <a:fld id="{5BCAD085-E8A6-8845-BD4E-CB4CCA059FC4}" type="datetimeFigureOut">
               <a:rPr lang="en-US" smtClean="0"/>
-              <a:t>1/27/13</a:t>
+              <a:t>9/3/2026</a:t>
             </a:fld>
             <a:endParaRPr lang="en-US"/>
           </a:p>
@@ -1903,10 +1904,9 @@
           <a:lstStyle/>
           <a:p>
             <a:r>
-              <a:rPr lang="en-US" smtClean="0"/>
+              <a:rPr lang="en-US"/>
               <a:t>Click to edit Master title style</a:t>
             </a:r>
-            <a:endParaRPr lang="en-US"/>
           </a:p>
         </p:txBody>
       </p:sp>
@@ -1927,7 +1927,7 @@
           <a:p>
             <a:fld id="{5BCAD085-E8A6-8845-BD4E-CB4CCA059FC4}" type="datetimeFigureOut">
               <a:rPr lang="en-US" smtClean="0"/>
-              <a:t>1/27/13</a:t>
+              <a:t>9/3/2026</a:t>
             </a:fld>
             <a:endParaRPr lang="en-US"/>
           </a:p>
@@ -2022,7 +2022,7 @@
           <a:p>
             <a:fld id="{5BCAD085-E8A6-8845-BD4E-CB4CCA059FC4}" type="datetimeFigureOut">
               <a:rPr lang="en-US" smtClean="0"/>
-              <a:t>1/27/13</a:t>
+              <a:t>9/3/2026</a:t>
             </a:fld>
             <a:endParaRPr lang="en-US"/>
           </a:p>
@@ -2125,10 +2125,9 @@
           </a:lstStyle>
           <a:p>
             <a:r>
-              <a:rPr lang="en-US" smtClean="0"/>
+              <a:rPr lang="en-US"/>
               <a:t>Click to edit Master title style</a:t>
             </a:r>
-            <a:endParaRPr lang="en-US"/>
           </a:p>
         </p:txBody>
       </p:sp>
@@ -2182,38 +2181,37 @@
           <a:p>
             <a:pPr lvl="0"/>
             <a:r>
-              <a:rPr lang="en-US" smtClean="0"/>
+              <a:rPr lang="en-US"/>
               <a:t>Click to edit Master text styles</a:t>
             </a:r>
           </a:p>
           <a:p>
             <a:pPr lvl="1"/>
             <a:r>
-              <a:rPr lang="en-US" smtClean="0"/>
+              <a:rPr lang="en-US"/>
               <a:t>Second level</a:t>
             </a:r>
           </a:p>
           <a:p>
             <a:pPr lvl="2"/>
             <a:r>
-              <a:rPr lang="en-US" smtClean="0"/>
+              <a:rPr lang="en-US"/>
               <a:t>Third level</a:t>
             </a:r>
           </a:p>
           <a:p>
             <a:pPr lvl="3"/>
             <a:r>
-              <a:rPr lang="en-US" smtClean="0"/>
+              <a:rPr lang="en-US"/>
               <a:t>Fourth level</a:t>
             </a:r>
           </a:p>
           <a:p>
             <a:pPr lvl="4"/>
             <a:r>
-              <a:rPr lang="en-US" smtClean="0"/>
+              <a:rPr lang="en-US"/>
               <a:t>Fifth level</a:t>
             </a:r>
-            <a:endParaRPr lang="en-US"/>
           </a:p>
         </p:txBody>
       </p:sp>
@@ -2276,7 +2274,7 @@
           <a:p>
             <a:pPr lvl="0"/>
             <a:r>
-              <a:rPr lang="en-US" smtClean="0"/>
+              <a:rPr lang="en-US"/>
               <a:t>Click to edit Master text styles</a:t>
             </a:r>
           </a:p>
@@ -2299,7 +2297,7 @@
           <a:p>
             <a:fld id="{5BCAD085-E8A6-8845-BD4E-CB4CCA059FC4}" type="datetimeFigureOut">
               <a:rPr lang="en-US" smtClean="0"/>
-              <a:t>1/27/13</a:t>
+              <a:t>9/3/2026</a:t>
             </a:fld>
             <a:endParaRPr lang="en-US"/>
           </a:p>
@@ -2402,10 +2400,9 @@
           </a:lstStyle>
           <a:p>
             <a:r>
-              <a:rPr lang="en-US" smtClean="0"/>
+              <a:rPr lang="en-US"/>
               <a:t>Click to edit Master title style</a:t>
             </a:r>
-            <a:endParaRPr lang="en-US"/>
           </a:p>
         </p:txBody>
       </p:sp>
@@ -2529,7 +2526,7 @@
           <a:p>
             <a:pPr lvl="0"/>
             <a:r>
-              <a:rPr lang="en-US" smtClean="0"/>
+              <a:rPr lang="en-US"/>
               <a:t>Click to edit Master text styles</a:t>
             </a:r>
           </a:p>
@@ -2552,7 +2549,7 @@
           <a:p>
             <a:fld id="{5BCAD085-E8A6-8845-BD4E-CB4CCA059FC4}" type="datetimeFigureOut">
               <a:rPr lang="en-US" smtClean="0"/>
-              <a:t>1/27/13</a:t>
+              <a:t>9/3/2026</a:t>
             </a:fld>
             <a:endParaRPr lang="en-US"/>
           </a:p>
@@ -2661,10 +2658,9 @@
           <a:lstStyle/>
           <a:p>
             <a:r>
-              <a:rPr lang="en-US" smtClean="0"/>
+              <a:rPr lang="en-US"/>
               <a:t>Click to edit Master title style</a:t>
             </a:r>
-            <a:endParaRPr lang="en-US"/>
           </a:p>
         </p:txBody>
       </p:sp>
@@ -2695,38 +2691,37 @@
           <a:p>
             <a:pPr lvl="0"/>
             <a:r>
-              <a:rPr lang="en-US" smtClean="0"/>
+              <a:rPr lang="en-US"/>
               <a:t>Click to edit Master text styles</a:t>
             </a:r>
           </a:p>
           <a:p>
             <a:pPr lvl="1"/>
             <a:r>
-              <a:rPr lang="en-US" smtClean="0"/>
+              <a:rPr lang="en-US"/>
               <a:t>Second level</a:t>
             </a:r>
           </a:p>
           <a:p>
             <a:pPr lvl="2"/>
             <a:r>
-              <a:rPr lang="en-US" smtClean="0"/>
+              <a:rPr lang="en-US"/>
               <a:t>Third level</a:t>
             </a:r>
           </a:p>
           <a:p>
             <a:pPr lvl="3"/>
             <a:r>
-              <a:rPr lang="en-US" smtClean="0"/>
+              <a:rPr lang="en-US"/>
               <a:t>Fourth level</a:t>
             </a:r>
           </a:p>
           <a:p>
             <a:pPr lvl="4"/>
             <a:r>
-              <a:rPr lang="en-US" smtClean="0"/>
+              <a:rPr lang="en-US"/>
               <a:t>Fifth level</a:t>
             </a:r>
-            <a:endParaRPr lang="en-US"/>
           </a:p>
         </p:txBody>
       </p:sp>
@@ -2765,7 +2760,7 @@
           <a:p>
             <a:fld id="{5BCAD085-E8A6-8845-BD4E-CB4CCA059FC4}" type="datetimeFigureOut">
               <a:rPr lang="en-US" smtClean="0"/>
-              <a:t>1/27/13</a:t>
+              <a:t>9/3/2026</a:t>
             </a:fld>
             <a:endParaRPr lang="en-US"/>
           </a:p>
@@ -3124,7 +3119,7 @@
 </file>
 
 <file path=ppt/slides/slide1.xml><?xml version="1.0" encoding="utf-8"?>
-<p:sld xmlns:a="http://schemas.openxmlformats.org/drawingml/2006/main" xmlns:p="http://schemas.openxmlformats.org/presentationml/2006/main" xmlns:r="http://schemas.openxmlformats.org/officeDocument/2006/relationships">
+<p:sld xmlns:a="http://schemas.openxmlformats.org/drawingml/2006/main" xmlns:r="http://schemas.openxmlformats.org/officeDocument/2006/relationships" xmlns:p="http://schemas.openxmlformats.org/presentationml/2006/main">
   <p:cSld>
     <p:bg>
       <p:bgPr>
@@ -3140,7 +3135,14 @@
         <p:cNvGrpSpPr/>
         <p:nvPr/>
       </p:nvGrpSpPr>
-      <p:grpSpPr/>
+      <p:grpSpPr>
+        <a:xfrm>
+          <a:off x="0" y="0"/>
+          <a:ext cx="0" cy="0"/>
+          <a:chOff x="0" y="0"/>
+          <a:chExt cx="0" cy="0"/>
+        </a:xfrm>
+      </p:grpSpPr>
       <p:sp>
         <p:nvSpPr>
           <p:cNvPr id="2" name="TextBox 1"/>
@@ -3220,7 +3222,7 @@
 </file>
 
 <file path=ppt/slides/slide10.xml><?xml version="1.0" encoding="utf-8"?>
-<p:sld xmlns:a="http://schemas.openxmlformats.org/drawingml/2006/main" xmlns:p="http://schemas.openxmlformats.org/presentationml/2006/main" xmlns:r="http://schemas.openxmlformats.org/officeDocument/2006/relationships">
+<p:sld xmlns:a="http://schemas.openxmlformats.org/drawingml/2006/main" xmlns:r="http://schemas.openxmlformats.org/officeDocument/2006/relationships" xmlns:p="http://schemas.openxmlformats.org/presentationml/2006/main">
   <p:cSld>
     <p:bg>
       <p:bgPr>
@@ -3236,7 +3238,14 @@
         <p:cNvGrpSpPr/>
         <p:nvPr/>
       </p:nvGrpSpPr>
-      <p:grpSpPr/>
+      <p:grpSpPr>
+        <a:xfrm>
+          <a:off x="0" y="0"/>
+          <a:ext cx="0" cy="0"/>
+          <a:chOff x="0" y="0"/>
+          <a:chExt cx="0" cy="0"/>
+        </a:xfrm>
+      </p:grpSpPr>
       <p:sp>
         <p:nvSpPr>
           <p:cNvPr id="2" name="Rectangle 1"/>
@@ -3277,6 +3286,7 @@
           <a:lstStyle/>
           <a:p>
             <a:pPr algn="ctr"/>
+            <a:endParaRPr/>
           </a:p>
         </p:txBody>
       </p:sp>
@@ -3422,6 +3432,7 @@
                 </a:solidFill>
               </a:defRPr>
             </a:pPr>
+            <a:endParaRPr/>
           </a:p>
           <a:p>
             <a:pPr>
@@ -3494,7 +3505,7 @@
 </file>
 
 <file path=ppt/slides/slide11.xml><?xml version="1.0" encoding="utf-8"?>
-<p:sld xmlns:a="http://schemas.openxmlformats.org/drawingml/2006/main" xmlns:p="http://schemas.openxmlformats.org/presentationml/2006/main" xmlns:r="http://schemas.openxmlformats.org/officeDocument/2006/relationships">
+<p:sld xmlns:a="http://schemas.openxmlformats.org/drawingml/2006/main" xmlns:r="http://schemas.openxmlformats.org/officeDocument/2006/relationships" xmlns:p="http://schemas.openxmlformats.org/presentationml/2006/main">
   <p:cSld>
     <p:bg>
       <p:bgPr>
@@ -3510,7 +3521,14 @@
         <p:cNvGrpSpPr/>
         <p:nvPr/>
       </p:nvGrpSpPr>
-      <p:grpSpPr/>
+      <p:grpSpPr>
+        <a:xfrm>
+          <a:off x="0" y="0"/>
+          <a:ext cx="0" cy="0"/>
+          <a:chOff x="0" y="0"/>
+          <a:chExt cx="0" cy="0"/>
+        </a:xfrm>
+      </p:grpSpPr>
       <p:sp>
         <p:nvSpPr>
           <p:cNvPr id="2" name="Rectangle 1"/>
@@ -3551,6 +3569,7 @@
           <a:lstStyle/>
           <a:p>
             <a:pPr algn="ctr"/>
+            <a:endParaRPr/>
           </a:p>
         </p:txBody>
       </p:sp>
@@ -3711,7 +3730,7 @@
 </file>
 
 <file path=ppt/slides/slide12.xml><?xml version="1.0" encoding="utf-8"?>
-<p:sld xmlns:a="http://schemas.openxmlformats.org/drawingml/2006/main" xmlns:p="http://schemas.openxmlformats.org/presentationml/2006/main" xmlns:r="http://schemas.openxmlformats.org/officeDocument/2006/relationships">
+<p:sld xmlns:a="http://schemas.openxmlformats.org/drawingml/2006/main" xmlns:r="http://schemas.openxmlformats.org/officeDocument/2006/relationships" xmlns:p="http://schemas.openxmlformats.org/presentationml/2006/main">
   <p:cSld>
     <p:bg>
       <p:bgPr>
@@ -3727,7 +3746,14 @@
         <p:cNvGrpSpPr/>
         <p:nvPr/>
       </p:nvGrpSpPr>
-      <p:grpSpPr/>
+      <p:grpSpPr>
+        <a:xfrm>
+          <a:off x="0" y="0"/>
+          <a:ext cx="0" cy="0"/>
+          <a:chOff x="0" y="0"/>
+          <a:chExt cx="0" cy="0"/>
+        </a:xfrm>
+      </p:grpSpPr>
       <p:sp>
         <p:nvSpPr>
           <p:cNvPr id="2" name="Rectangle 1"/>
@@ -3768,6 +3794,7 @@
           <a:lstStyle/>
           <a:p>
             <a:pPr algn="ctr"/>
+            <a:endParaRPr/>
           </a:p>
         </p:txBody>
       </p:sp>
@@ -3928,7 +3955,7 @@
 </file>
 
 <file path=ppt/slides/slide13.xml><?xml version="1.0" encoding="utf-8"?>
-<p:sld xmlns:a="http://schemas.openxmlformats.org/drawingml/2006/main" xmlns:p="http://schemas.openxmlformats.org/presentationml/2006/main" xmlns:r="http://schemas.openxmlformats.org/officeDocument/2006/relationships">
+<p:sld xmlns:a="http://schemas.openxmlformats.org/drawingml/2006/main" xmlns:r="http://schemas.openxmlformats.org/officeDocument/2006/relationships" xmlns:p="http://schemas.openxmlformats.org/presentationml/2006/main">
   <p:cSld>
     <p:bg>
       <p:bgPr>
@@ -3944,7 +3971,14 @@
         <p:cNvGrpSpPr/>
         <p:nvPr/>
       </p:nvGrpSpPr>
-      <p:grpSpPr/>
+      <p:grpSpPr>
+        <a:xfrm>
+          <a:off x="0" y="0"/>
+          <a:ext cx="0" cy="0"/>
+          <a:chOff x="0" y="0"/>
+          <a:chExt cx="0" cy="0"/>
+        </a:xfrm>
+      </p:grpSpPr>
       <p:sp>
         <p:nvSpPr>
           <p:cNvPr id="2" name="Rectangle 1"/>
@@ -3985,6 +4019,7 @@
           <a:lstStyle/>
           <a:p>
             <a:pPr algn="ctr"/>
+            <a:endParaRPr/>
           </a:p>
         </p:txBody>
       </p:sp>
@@ -4115,6 +4150,7 @@
                 </a:solidFill>
               </a:defRPr>
             </a:pPr>
+            <a:endParaRPr/>
           </a:p>
           <a:p>
             <a:pPr>
@@ -4202,7 +4238,7 @@
 </file>
 
 <file path=ppt/slides/slide14.xml><?xml version="1.0" encoding="utf-8"?>
-<p:sld xmlns:a="http://schemas.openxmlformats.org/drawingml/2006/main" xmlns:p="http://schemas.openxmlformats.org/presentationml/2006/main" xmlns:r="http://schemas.openxmlformats.org/officeDocument/2006/relationships">
+<p:sld xmlns:a="http://schemas.openxmlformats.org/drawingml/2006/main" xmlns:r="http://schemas.openxmlformats.org/officeDocument/2006/relationships" xmlns:p="http://schemas.openxmlformats.org/presentationml/2006/main">
   <p:cSld>
     <p:bg>
       <p:bgPr>
@@ -4218,7 +4254,14 @@
         <p:cNvGrpSpPr/>
         <p:nvPr/>
       </p:nvGrpSpPr>
-      <p:grpSpPr/>
+      <p:grpSpPr>
+        <a:xfrm>
+          <a:off x="0" y="0"/>
+          <a:ext cx="0" cy="0"/>
+          <a:chOff x="0" y="0"/>
+          <a:chExt cx="0" cy="0"/>
+        </a:xfrm>
+      </p:grpSpPr>
       <p:sp>
         <p:nvSpPr>
           <p:cNvPr id="2" name="Rectangle 1"/>
@@ -4259,6 +4302,7 @@
           <a:lstStyle/>
           <a:p>
             <a:pPr algn="ctr"/>
+            <a:endParaRPr/>
           </a:p>
         </p:txBody>
       </p:sp>
@@ -4405,7 +4449,7 @@
 </file>
 
 <file path=ppt/slides/slide15.xml><?xml version="1.0" encoding="utf-8"?>
-<p:sld xmlns:a="http://schemas.openxmlformats.org/drawingml/2006/main" xmlns:p="http://schemas.openxmlformats.org/presentationml/2006/main" xmlns:r="http://schemas.openxmlformats.org/officeDocument/2006/relationships">
+<p:sld xmlns:a="http://schemas.openxmlformats.org/drawingml/2006/main" xmlns:r="http://schemas.openxmlformats.org/officeDocument/2006/relationships" xmlns:p="http://schemas.openxmlformats.org/presentationml/2006/main">
   <p:cSld>
     <p:bg>
       <p:bgPr>
@@ -4421,7 +4465,14 @@
         <p:cNvGrpSpPr/>
         <p:nvPr/>
       </p:nvGrpSpPr>
-      <p:grpSpPr/>
+      <p:grpSpPr>
+        <a:xfrm>
+          <a:off x="0" y="0"/>
+          <a:ext cx="0" cy="0"/>
+          <a:chOff x="0" y="0"/>
+          <a:chExt cx="0" cy="0"/>
+        </a:xfrm>
+      </p:grpSpPr>
       <p:sp>
         <p:nvSpPr>
           <p:cNvPr id="2" name="Rectangle 1"/>
@@ -4462,6 +4513,7 @@
           <a:lstStyle/>
           <a:p>
             <a:pPr algn="ctr"/>
+            <a:endParaRPr/>
           </a:p>
         </p:txBody>
       </p:sp>
@@ -4608,7 +4660,7 @@
 </file>
 
 <file path=ppt/slides/slide16.xml><?xml version="1.0" encoding="utf-8"?>
-<p:sld xmlns:a="http://schemas.openxmlformats.org/drawingml/2006/main" xmlns:p="http://schemas.openxmlformats.org/presentationml/2006/main" xmlns:r="http://schemas.openxmlformats.org/officeDocument/2006/relationships">
+<p:sld xmlns:a="http://schemas.openxmlformats.org/drawingml/2006/main" xmlns:r="http://schemas.openxmlformats.org/officeDocument/2006/relationships" xmlns:p="http://schemas.openxmlformats.org/presentationml/2006/main">
   <p:cSld>
     <p:bg>
       <p:bgPr>
@@ -4624,7 +4676,14 @@
         <p:cNvGrpSpPr/>
         <p:nvPr/>
       </p:nvGrpSpPr>
-      <p:grpSpPr/>
+      <p:grpSpPr>
+        <a:xfrm>
+          <a:off x="0" y="0"/>
+          <a:ext cx="0" cy="0"/>
+          <a:chOff x="0" y="0"/>
+          <a:chExt cx="0" cy="0"/>
+        </a:xfrm>
+      </p:grpSpPr>
       <p:sp>
         <p:nvSpPr>
           <p:cNvPr id="2" name="Rectangle 1"/>
@@ -4665,6 +4724,7 @@
           <a:lstStyle/>
           <a:p>
             <a:pPr algn="ctr"/>
+            <a:endParaRPr/>
           </a:p>
         </p:txBody>
       </p:sp>
@@ -4825,7 +4885,7 @@
 </file>
 
 <file path=ppt/slides/slide17.xml><?xml version="1.0" encoding="utf-8"?>
-<p:sld xmlns:a="http://schemas.openxmlformats.org/drawingml/2006/main" xmlns:p="http://schemas.openxmlformats.org/presentationml/2006/main" xmlns:r="http://schemas.openxmlformats.org/officeDocument/2006/relationships">
+<p:sld xmlns:a="http://schemas.openxmlformats.org/drawingml/2006/main" xmlns:r="http://schemas.openxmlformats.org/officeDocument/2006/relationships" xmlns:p="http://schemas.openxmlformats.org/presentationml/2006/main">
   <p:cSld>
     <p:bg>
       <p:bgPr>
@@ -4841,7 +4901,14 @@
         <p:cNvGrpSpPr/>
         <p:nvPr/>
       </p:nvGrpSpPr>
-      <p:grpSpPr/>
+      <p:grpSpPr>
+        <a:xfrm>
+          <a:off x="0" y="0"/>
+          <a:ext cx="0" cy="0"/>
+          <a:chOff x="0" y="0"/>
+          <a:chExt cx="0" cy="0"/>
+        </a:xfrm>
+      </p:grpSpPr>
       <p:sp>
         <p:nvSpPr>
           <p:cNvPr id="2" name="Rectangle 1"/>
@@ -4882,6 +4949,7 @@
           <a:lstStyle/>
           <a:p>
             <a:pPr algn="ctr"/>
+            <a:endParaRPr/>
           </a:p>
         </p:txBody>
       </p:sp>
@@ -4953,6 +5021,7 @@
               </a:defRPr>
             </a:pPr>
             <a:r>
+              <a:rPr dirty="0"/>
               <a:t>1. FROM (including JOINs)</a:t>
             </a:r>
           </a:p>
@@ -4968,6 +5037,7 @@
               </a:defRPr>
             </a:pPr>
             <a:r>
+              <a:rPr dirty="0"/>
               <a:t>2. WHERE</a:t>
             </a:r>
           </a:p>
@@ -4983,6 +5053,7 @@
               </a:defRPr>
             </a:pPr>
             <a:r>
+              <a:rPr dirty="0"/>
               <a:t>3. GROUP BY</a:t>
             </a:r>
           </a:p>
@@ -4998,6 +5069,7 @@
               </a:defRPr>
             </a:pPr>
             <a:r>
+              <a:rPr dirty="0"/>
               <a:t>4. HAVING</a:t>
             </a:r>
           </a:p>
@@ -5013,6 +5085,7 @@
               </a:defRPr>
             </a:pPr>
             <a:r>
+              <a:rPr dirty="0"/>
               <a:t>5. SELECT</a:t>
             </a:r>
           </a:p>
@@ -5028,6 +5101,7 @@
               </a:defRPr>
             </a:pPr>
             <a:r>
+              <a:rPr dirty="0"/>
               <a:t>6. DISTINCT</a:t>
             </a:r>
           </a:p>
@@ -5043,6 +5117,7 @@
               </a:defRPr>
             </a:pPr>
             <a:r>
+              <a:rPr dirty="0"/>
               <a:t>7. ORDER BY</a:t>
             </a:r>
           </a:p>
@@ -5058,6 +5133,7 @@
               </a:defRPr>
             </a:pPr>
             <a:r>
+              <a:rPr dirty="0"/>
               <a:t>8. TOP / OFFSET-FETCH</a:t>
             </a:r>
           </a:p>
@@ -5072,6 +5148,7 @@
                 </a:solidFill>
               </a:defRPr>
             </a:pPr>
+            <a:endParaRPr dirty="0"/>
           </a:p>
           <a:p>
             <a:pPr>
@@ -5085,6 +5162,7 @@
               </a:defRPr>
             </a:pPr>
             <a:r>
+              <a:rPr dirty="0"/>
               <a:t>Key Point: Logical ≠ Physical execution order</a:t>
             </a:r>
           </a:p>
@@ -5099,7 +5177,7 @@
 </file>
 
 <file path=ppt/slides/slide18.xml><?xml version="1.0" encoding="utf-8"?>
-<p:sld xmlns:a="http://schemas.openxmlformats.org/drawingml/2006/main" xmlns:p="http://schemas.openxmlformats.org/presentationml/2006/main" xmlns:r="http://schemas.openxmlformats.org/officeDocument/2006/relationships">
+<p:sld xmlns:a="http://schemas.openxmlformats.org/drawingml/2006/main" xmlns:r="http://schemas.openxmlformats.org/officeDocument/2006/relationships" xmlns:p="http://schemas.openxmlformats.org/presentationml/2006/main">
   <p:cSld>
     <p:bg>
       <p:bgPr>
@@ -5115,7 +5193,14 @@
         <p:cNvGrpSpPr/>
         <p:nvPr/>
       </p:nvGrpSpPr>
-      <p:grpSpPr/>
+      <p:grpSpPr>
+        <a:xfrm>
+          <a:off x="0" y="0"/>
+          <a:ext cx="0" cy="0"/>
+          <a:chOff x="0" y="0"/>
+          <a:chExt cx="0" cy="0"/>
+        </a:xfrm>
+      </p:grpSpPr>
       <p:sp>
         <p:nvSpPr>
           <p:cNvPr id="2" name="Rectangle 1"/>
@@ -5156,6 +5241,7 @@
           <a:lstStyle/>
           <a:p>
             <a:pPr algn="ctr"/>
+            <a:endParaRPr/>
           </a:p>
         </p:txBody>
       </p:sp>
@@ -5313,6 +5399,7 @@
                 <a:latin typeface="Consolas"/>
               </a:defRPr>
             </a:pPr>
+            <a:endParaRPr/>
           </a:p>
           <a:p>
             <a:pPr>
@@ -5377,7 +5464,7 @@
 </file>
 
 <file path=ppt/slides/slide19.xml><?xml version="1.0" encoding="utf-8"?>
-<p:sld xmlns:a="http://schemas.openxmlformats.org/drawingml/2006/main" xmlns:p="http://schemas.openxmlformats.org/presentationml/2006/main" xmlns:r="http://schemas.openxmlformats.org/officeDocument/2006/relationships">
+<p:sld xmlns:a="http://schemas.openxmlformats.org/drawingml/2006/main" xmlns:r="http://schemas.openxmlformats.org/officeDocument/2006/relationships" xmlns:p="http://schemas.openxmlformats.org/presentationml/2006/main">
   <p:cSld>
     <p:bg>
       <p:bgPr>
@@ -5393,7 +5480,14 @@
         <p:cNvGrpSpPr/>
         <p:nvPr/>
       </p:nvGrpSpPr>
-      <p:grpSpPr/>
+      <p:grpSpPr>
+        <a:xfrm>
+          <a:off x="0" y="0"/>
+          <a:ext cx="0" cy="0"/>
+          <a:chOff x="0" y="0"/>
+          <a:chExt cx="0" cy="0"/>
+        </a:xfrm>
+      </p:grpSpPr>
       <p:sp>
         <p:nvSpPr>
           <p:cNvPr id="2" name="Rectangle 1"/>
@@ -5434,6 +5528,7 @@
           <a:lstStyle/>
           <a:p>
             <a:pPr algn="ctr"/>
+            <a:endParaRPr/>
           </a:p>
         </p:txBody>
       </p:sp>
@@ -5606,7 +5701,7 @@
 </file>
 
 <file path=ppt/slides/slide2.xml><?xml version="1.0" encoding="utf-8"?>
-<p:sld xmlns:a="http://schemas.openxmlformats.org/drawingml/2006/main" xmlns:p="http://schemas.openxmlformats.org/presentationml/2006/main" xmlns:r="http://schemas.openxmlformats.org/officeDocument/2006/relationships">
+<p:sld xmlns:a="http://schemas.openxmlformats.org/drawingml/2006/main" xmlns:r="http://schemas.openxmlformats.org/officeDocument/2006/relationships" xmlns:p="http://schemas.openxmlformats.org/presentationml/2006/main">
   <p:cSld>
     <p:bg>
       <p:bgPr>
@@ -5622,7 +5717,14 @@
         <p:cNvGrpSpPr/>
         <p:nvPr/>
       </p:nvGrpSpPr>
-      <p:grpSpPr/>
+      <p:grpSpPr>
+        <a:xfrm>
+          <a:off x="0" y="0"/>
+          <a:ext cx="0" cy="0"/>
+          <a:chOff x="0" y="0"/>
+          <a:chExt cx="0" cy="0"/>
+        </a:xfrm>
+      </p:grpSpPr>
       <p:sp>
         <p:nvSpPr>
           <p:cNvPr id="2" name="Rectangle 1"/>
@@ -5663,6 +5765,7 @@
           <a:lstStyle/>
           <a:p>
             <a:pPr algn="ctr"/>
+            <a:endParaRPr/>
           </a:p>
         </p:txBody>
       </p:sp>
@@ -5710,7 +5813,7 @@
         <p:spPr>
           <a:xfrm>
             <a:off x="640080" y="1188720"/>
-            <a:ext cx="7863840" cy="5212080"/>
+            <a:ext cx="7863840" cy="4216539"/>
           </a:xfrm>
           <a:prstGeom prst="rect">
             <a:avLst/>
@@ -5734,6 +5837,23 @@
               </a:defRPr>
             </a:pPr>
             <a:r>
+              <a:rPr lang="en-US" b="1" dirty="0"/>
+              <a:t>Today’s topics</a:t>
+            </a:r>
+          </a:p>
+          <a:p>
+            <a:pPr>
+              <a:spcBef>
+                <a:spcPts val="600"/>
+              </a:spcBef>
+              <a:defRPr sz="1600">
+                <a:solidFill>
+                  <a:srgbClr val="424242"/>
+                </a:solidFill>
+              </a:defRPr>
+            </a:pPr>
+            <a:r>
+              <a:rPr dirty="0"/>
               <a:t>1. Index Structures and Maintenance</a:t>
             </a:r>
           </a:p>
@@ -5749,6 +5869,7 @@
               </a:defRPr>
             </a:pPr>
             <a:r>
+              <a:rPr dirty="0"/>
               <a:t>2. Reading and Optimizing Execution Plans</a:t>
             </a:r>
           </a:p>
@@ -5764,6 +5885,7 @@
               </a:defRPr>
             </a:pPr>
             <a:r>
+              <a:rPr dirty="0"/>
               <a:t>3. Advanced Index Techniques</a:t>
             </a:r>
           </a:p>
@@ -5779,6 +5901,7 @@
               </a:defRPr>
             </a:pPr>
             <a:r>
+              <a:rPr dirty="0"/>
               <a:t>4. Query Processing Order</a:t>
             </a:r>
           </a:p>
@@ -5794,6 +5917,7 @@
               </a:defRPr>
             </a:pPr>
             <a:r>
+              <a:rPr dirty="0"/>
               <a:t>5. Implicit Conversions</a:t>
             </a:r>
           </a:p>
@@ -5809,6 +5933,7 @@
               </a:defRPr>
             </a:pPr>
             <a:r>
+              <a:rPr dirty="0"/>
               <a:t>6. Query Anti-Patterns to Avoid</a:t>
             </a:r>
           </a:p>
@@ -5824,6 +5949,7 @@
               </a:defRPr>
             </a:pPr>
             <a:r>
+              <a:rPr dirty="0"/>
               <a:t>7. Query Best Practices</a:t>
             </a:r>
           </a:p>
@@ -5839,6 +5965,7 @@
               </a:defRPr>
             </a:pPr>
             <a:r>
+              <a:rPr dirty="0"/>
               <a:t>8. Table-Valued Functions</a:t>
             </a:r>
           </a:p>
@@ -5853,8 +5980,54 @@
                 </a:solidFill>
               </a:defRPr>
             </a:pPr>
-            <a:r>
-              <a:t>9. Parameter Sniffing Solutions</a:t>
+            <a:endParaRPr lang="en-US" dirty="0"/>
+          </a:p>
+          <a:p>
+            <a:pPr>
+              <a:spcBef>
+                <a:spcPts val="600"/>
+              </a:spcBef>
+              <a:defRPr sz="1600">
+                <a:solidFill>
+                  <a:srgbClr val="424242"/>
+                </a:solidFill>
+              </a:defRPr>
+            </a:pPr>
+            <a:r>
+              <a:rPr lang="en-US" b="1" dirty="0"/>
+              <a:t>Next week’s topics</a:t>
+            </a:r>
+          </a:p>
+          <a:p>
+            <a:pPr>
+              <a:spcBef>
+                <a:spcPts val="600"/>
+              </a:spcBef>
+              <a:defRPr sz="1600">
+                <a:solidFill>
+                  <a:srgbClr val="424242"/>
+                </a:solidFill>
+              </a:defRPr>
+            </a:pPr>
+            <a:r>
+              <a:rPr lang="en-US" dirty="0"/>
+              <a:t>9. Parameter Sniffing</a:t>
+            </a:r>
+          </a:p>
+          <a:p>
+            <a:pPr>
+              <a:spcBef>
+                <a:spcPts val="600"/>
+              </a:spcBef>
+              <a:defRPr sz="1600">
+                <a:solidFill>
+                  <a:srgbClr val="424242"/>
+                </a:solidFill>
+              </a:defRPr>
+            </a:pPr>
+            <a:r>
+              <a:rPr lang="en-US" dirty="0"/>
+              <a:t>10. Parameter Sniffing Solutions</a:t>
             </a:r>
           </a:p>
         </p:txBody>
@@ -5868,7 +6041,7 @@
 </file>
 
 <file path=ppt/slides/slide20.xml><?xml version="1.0" encoding="utf-8"?>
-<p:sld xmlns:a="http://schemas.openxmlformats.org/drawingml/2006/main" xmlns:p="http://schemas.openxmlformats.org/presentationml/2006/main" xmlns:r="http://schemas.openxmlformats.org/officeDocument/2006/relationships">
+<p:sld xmlns:a="http://schemas.openxmlformats.org/drawingml/2006/main" xmlns:r="http://schemas.openxmlformats.org/officeDocument/2006/relationships" xmlns:p="http://schemas.openxmlformats.org/presentationml/2006/main">
   <p:cSld>
     <p:bg>
       <p:bgPr>
@@ -5884,7 +6057,14 @@
         <p:cNvGrpSpPr/>
         <p:nvPr/>
       </p:nvGrpSpPr>
-      <p:grpSpPr/>
+      <p:grpSpPr>
+        <a:xfrm>
+          <a:off x="0" y="0"/>
+          <a:ext cx="0" cy="0"/>
+          <a:chOff x="0" y="0"/>
+          <a:chExt cx="0" cy="0"/>
+        </a:xfrm>
+      </p:grpSpPr>
       <p:sp>
         <p:nvSpPr>
           <p:cNvPr id="2" name="Rectangle 1"/>
@@ -5925,6 +6105,7 @@
           <a:lstStyle/>
           <a:p>
             <a:pPr algn="ctr"/>
+            <a:endParaRPr/>
           </a:p>
         </p:txBody>
       </p:sp>
@@ -6056,6 +6237,7 @@
                 <a:latin typeface="Consolas"/>
               </a:defRPr>
             </a:pPr>
+            <a:endParaRPr/>
           </a:p>
           <a:p>
             <a:pPr>
@@ -6094,7 +6276,7 @@
 </file>
 
 <file path=ppt/slides/slide21.xml><?xml version="1.0" encoding="utf-8"?>
-<p:sld xmlns:a="http://schemas.openxmlformats.org/drawingml/2006/main" xmlns:p="http://schemas.openxmlformats.org/presentationml/2006/main" xmlns:r="http://schemas.openxmlformats.org/officeDocument/2006/relationships">
+<p:sld xmlns:a="http://schemas.openxmlformats.org/drawingml/2006/main" xmlns:r="http://schemas.openxmlformats.org/officeDocument/2006/relationships" xmlns:p="http://schemas.openxmlformats.org/presentationml/2006/main">
   <p:cSld>
     <p:bg>
       <p:bgPr>
@@ -6110,7 +6292,14 @@
         <p:cNvGrpSpPr/>
         <p:nvPr/>
       </p:nvGrpSpPr>
-      <p:grpSpPr/>
+      <p:grpSpPr>
+        <a:xfrm>
+          <a:off x="0" y="0"/>
+          <a:ext cx="0" cy="0"/>
+          <a:chOff x="0" y="0"/>
+          <a:chExt cx="0" cy="0"/>
+        </a:xfrm>
+      </p:grpSpPr>
       <p:sp>
         <p:nvSpPr>
           <p:cNvPr id="2" name="Rectangle 1"/>
@@ -6151,6 +6340,7 @@
           <a:lstStyle/>
           <a:p>
             <a:pPr algn="ctr"/>
+            <a:endParaRPr/>
           </a:p>
         </p:txBody>
       </p:sp>
@@ -6281,6 +6471,7 @@
                 </a:solidFill>
               </a:defRPr>
             </a:pPr>
+            <a:endParaRPr/>
           </a:p>
           <a:p>
             <a:pPr>
@@ -6353,7 +6544,7 @@
 </file>
 
 <file path=ppt/slides/slide22.xml><?xml version="1.0" encoding="utf-8"?>
-<p:sld xmlns:a="http://schemas.openxmlformats.org/drawingml/2006/main" xmlns:p="http://schemas.openxmlformats.org/presentationml/2006/main" xmlns:r="http://schemas.openxmlformats.org/officeDocument/2006/relationships">
+<p:sld xmlns:a="http://schemas.openxmlformats.org/drawingml/2006/main" xmlns:r="http://schemas.openxmlformats.org/officeDocument/2006/relationships" xmlns:p="http://schemas.openxmlformats.org/presentationml/2006/main">
   <p:cSld>
     <p:bg>
       <p:bgPr>
@@ -6369,7 +6560,14 @@
         <p:cNvGrpSpPr/>
         <p:nvPr/>
       </p:nvGrpSpPr>
-      <p:grpSpPr/>
+      <p:grpSpPr>
+        <a:xfrm>
+          <a:off x="0" y="0"/>
+          <a:ext cx="0" cy="0"/>
+          <a:chOff x="0" y="0"/>
+          <a:chExt cx="0" cy="0"/>
+        </a:xfrm>
+      </p:grpSpPr>
       <p:sp>
         <p:nvSpPr>
           <p:cNvPr id="2" name="Rectangle 1"/>
@@ -6410,6 +6608,7 @@
           <a:lstStyle/>
           <a:p>
             <a:pPr algn="ctr"/>
+            <a:endParaRPr/>
           </a:p>
         </p:txBody>
       </p:sp>
@@ -6570,7 +6769,7 @@
 </file>
 
 <file path=ppt/slides/slide23.xml><?xml version="1.0" encoding="utf-8"?>
-<p:sld xmlns:a="http://schemas.openxmlformats.org/drawingml/2006/main" xmlns:p="http://schemas.openxmlformats.org/presentationml/2006/main" xmlns:r="http://schemas.openxmlformats.org/officeDocument/2006/relationships">
+<p:sld xmlns:a="http://schemas.openxmlformats.org/drawingml/2006/main" xmlns:r="http://schemas.openxmlformats.org/officeDocument/2006/relationships" xmlns:p="http://schemas.openxmlformats.org/presentationml/2006/main">
   <p:cSld>
     <p:bg>
       <p:bgPr>
@@ -6586,7 +6785,14 @@
         <p:cNvGrpSpPr/>
         <p:nvPr/>
       </p:nvGrpSpPr>
-      <p:grpSpPr/>
+      <p:grpSpPr>
+        <a:xfrm>
+          <a:off x="0" y="0"/>
+          <a:ext cx="0" cy="0"/>
+          <a:chOff x="0" y="0"/>
+          <a:chExt cx="0" cy="0"/>
+        </a:xfrm>
+      </p:grpSpPr>
       <p:sp>
         <p:nvSpPr>
           <p:cNvPr id="2" name="Rectangle 1"/>
@@ -6627,6 +6833,7 @@
           <a:lstStyle/>
           <a:p>
             <a:pPr algn="ctr"/>
+            <a:endParaRPr/>
           </a:p>
         </p:txBody>
       </p:sp>
@@ -6802,7 +7009,7 @@
 </file>
 
 <file path=ppt/slides/slide24.xml><?xml version="1.0" encoding="utf-8"?>
-<p:sld xmlns:a="http://schemas.openxmlformats.org/drawingml/2006/main" xmlns:p="http://schemas.openxmlformats.org/presentationml/2006/main" xmlns:r="http://schemas.openxmlformats.org/officeDocument/2006/relationships">
+<p:sld xmlns:a="http://schemas.openxmlformats.org/drawingml/2006/main" xmlns:r="http://schemas.openxmlformats.org/officeDocument/2006/relationships" xmlns:p="http://schemas.openxmlformats.org/presentationml/2006/main">
   <p:cSld>
     <p:bg>
       <p:bgPr>
@@ -6818,7 +7025,14 @@
         <p:cNvGrpSpPr/>
         <p:nvPr/>
       </p:nvGrpSpPr>
-      <p:grpSpPr/>
+      <p:grpSpPr>
+        <a:xfrm>
+          <a:off x="0" y="0"/>
+          <a:ext cx="0" cy="0"/>
+          <a:chOff x="0" y="0"/>
+          <a:chExt cx="0" cy="0"/>
+        </a:xfrm>
+      </p:grpSpPr>
       <p:sp>
         <p:nvSpPr>
           <p:cNvPr id="2" name="Rectangle 1"/>
@@ -6859,6 +7073,7 @@
           <a:lstStyle/>
           <a:p>
             <a:pPr algn="ctr"/>
+            <a:endParaRPr/>
           </a:p>
         </p:txBody>
       </p:sp>
@@ -7003,6 +7218,7 @@
                 <a:latin typeface="Consolas"/>
               </a:defRPr>
             </a:pPr>
+            <a:endParaRPr/>
           </a:p>
           <a:p>
             <a:pPr>
@@ -7067,7 +7283,7 @@
 </file>
 
 <file path=ppt/slides/slide25.xml><?xml version="1.0" encoding="utf-8"?>
-<p:sld xmlns:a="http://schemas.openxmlformats.org/drawingml/2006/main" xmlns:p="http://schemas.openxmlformats.org/presentationml/2006/main" xmlns:r="http://schemas.openxmlformats.org/officeDocument/2006/relationships">
+<p:sld xmlns:a="http://schemas.openxmlformats.org/drawingml/2006/main" xmlns:r="http://schemas.openxmlformats.org/officeDocument/2006/relationships" xmlns:p="http://schemas.openxmlformats.org/presentationml/2006/main">
   <p:cSld>
     <p:bg>
       <p:bgPr>
@@ -7083,7 +7299,14 @@
         <p:cNvGrpSpPr/>
         <p:nvPr/>
       </p:nvGrpSpPr>
-      <p:grpSpPr/>
+      <p:grpSpPr>
+        <a:xfrm>
+          <a:off x="0" y="0"/>
+          <a:ext cx="0" cy="0"/>
+          <a:chOff x="0" y="0"/>
+          <a:chExt cx="0" cy="0"/>
+        </a:xfrm>
+      </p:grpSpPr>
       <p:sp>
         <p:nvSpPr>
           <p:cNvPr id="2" name="Rectangle 1"/>
@@ -7124,6 +7347,7 @@
           <a:lstStyle/>
           <a:p>
             <a:pPr algn="ctr"/>
+            <a:endParaRPr/>
           </a:p>
         </p:txBody>
       </p:sp>
@@ -7307,6 +7531,7 @@
                 <a:latin typeface="Consolas"/>
               </a:defRPr>
             </a:pPr>
+            <a:endParaRPr/>
           </a:p>
           <a:p>
             <a:pPr>
@@ -7371,7 +7596,7 @@
 </file>
 
 <file path=ppt/slides/slide26.xml><?xml version="1.0" encoding="utf-8"?>
-<p:sld xmlns:a="http://schemas.openxmlformats.org/drawingml/2006/main" xmlns:p="http://schemas.openxmlformats.org/presentationml/2006/main" xmlns:r="http://schemas.openxmlformats.org/officeDocument/2006/relationships">
+<p:sld xmlns:a="http://schemas.openxmlformats.org/drawingml/2006/main" xmlns:r="http://schemas.openxmlformats.org/officeDocument/2006/relationships" xmlns:p="http://schemas.openxmlformats.org/presentationml/2006/main">
   <p:cSld>
     <p:bg>
       <p:bgPr>
@@ -7387,7 +7612,14 @@
         <p:cNvGrpSpPr/>
         <p:nvPr/>
       </p:nvGrpSpPr>
-      <p:grpSpPr/>
+      <p:grpSpPr>
+        <a:xfrm>
+          <a:off x="0" y="0"/>
+          <a:ext cx="0" cy="0"/>
+          <a:chOff x="0" y="0"/>
+          <a:chExt cx="0" cy="0"/>
+        </a:xfrm>
+      </p:grpSpPr>
       <p:sp>
         <p:nvSpPr>
           <p:cNvPr id="2" name="Rectangle 1"/>
@@ -7428,6 +7660,7 @@
           <a:lstStyle/>
           <a:p>
             <a:pPr algn="ctr"/>
+            <a:endParaRPr/>
           </a:p>
         </p:txBody>
       </p:sp>
@@ -7588,7 +7821,7 @@
 </file>
 
 <file path=ppt/slides/slide27.xml><?xml version="1.0" encoding="utf-8"?>
-<p:sld xmlns:a="http://schemas.openxmlformats.org/drawingml/2006/main" xmlns:p="http://schemas.openxmlformats.org/presentationml/2006/main" xmlns:r="http://schemas.openxmlformats.org/officeDocument/2006/relationships">
+<p:sld xmlns:a="http://schemas.openxmlformats.org/drawingml/2006/main" xmlns:r="http://schemas.openxmlformats.org/officeDocument/2006/relationships" xmlns:p="http://schemas.openxmlformats.org/presentationml/2006/main">
   <p:cSld>
     <p:bg>
       <p:bgPr>
@@ -7604,7 +7837,14 @@
         <p:cNvGrpSpPr/>
         <p:nvPr/>
       </p:nvGrpSpPr>
-      <p:grpSpPr/>
+      <p:grpSpPr>
+        <a:xfrm>
+          <a:off x="0" y="0"/>
+          <a:ext cx="0" cy="0"/>
+          <a:chOff x="0" y="0"/>
+          <a:chExt cx="0" cy="0"/>
+        </a:xfrm>
+      </p:grpSpPr>
       <p:sp>
         <p:nvSpPr>
           <p:cNvPr id="2" name="Rectangle 1"/>
@@ -7645,6 +7885,7 @@
           <a:lstStyle/>
           <a:p>
             <a:pPr algn="ctr"/>
+            <a:endParaRPr/>
           </a:p>
         </p:txBody>
       </p:sp>
@@ -7820,7 +8061,7 @@
 </file>
 
 <file path=ppt/slides/slide28.xml><?xml version="1.0" encoding="utf-8"?>
-<p:sld xmlns:a="http://schemas.openxmlformats.org/drawingml/2006/main" xmlns:p="http://schemas.openxmlformats.org/presentationml/2006/main" xmlns:r="http://schemas.openxmlformats.org/officeDocument/2006/relationships">
+<p:sld xmlns:a="http://schemas.openxmlformats.org/drawingml/2006/main" xmlns:r="http://schemas.openxmlformats.org/officeDocument/2006/relationships" xmlns:p="http://schemas.openxmlformats.org/presentationml/2006/main">
   <p:cSld>
     <p:bg>
       <p:bgPr>
@@ -7836,7 +8077,14 @@
         <p:cNvGrpSpPr/>
         <p:nvPr/>
       </p:nvGrpSpPr>
-      <p:grpSpPr/>
+      <p:grpSpPr>
+        <a:xfrm>
+          <a:off x="0" y="0"/>
+          <a:ext cx="0" cy="0"/>
+          <a:chOff x="0" y="0"/>
+          <a:chExt cx="0" cy="0"/>
+        </a:xfrm>
+      </p:grpSpPr>
       <p:sp>
         <p:nvSpPr>
           <p:cNvPr id="2" name="Rectangle 1"/>
@@ -7877,6 +8125,7 @@
           <a:lstStyle/>
           <a:p>
             <a:pPr algn="ctr"/>
+            <a:endParaRPr/>
           </a:p>
         </p:txBody>
       </p:sp>
@@ -8153,7 +8402,7 @@
 </file>
 
 <file path=ppt/slides/slide29.xml><?xml version="1.0" encoding="utf-8"?>
-<p:sld xmlns:a="http://schemas.openxmlformats.org/drawingml/2006/main" xmlns:p="http://schemas.openxmlformats.org/presentationml/2006/main" xmlns:r="http://schemas.openxmlformats.org/officeDocument/2006/relationships">
+<p:sld xmlns:a="http://schemas.openxmlformats.org/drawingml/2006/main" xmlns:r="http://schemas.openxmlformats.org/officeDocument/2006/relationships" xmlns:p="http://schemas.openxmlformats.org/presentationml/2006/main">
   <p:cSld>
     <p:bg>
       <p:bgPr>
@@ -8169,7 +8418,14 @@
         <p:cNvGrpSpPr/>
         <p:nvPr/>
       </p:nvGrpSpPr>
-      <p:grpSpPr/>
+      <p:grpSpPr>
+        <a:xfrm>
+          <a:off x="0" y="0"/>
+          <a:ext cx="0" cy="0"/>
+          <a:chOff x="0" y="0"/>
+          <a:chExt cx="0" cy="0"/>
+        </a:xfrm>
+      </p:grpSpPr>
       <p:sp>
         <p:nvSpPr>
           <p:cNvPr id="2" name="Rectangle 1"/>
@@ -8210,6 +8466,7 @@
           <a:lstStyle/>
           <a:p>
             <a:pPr algn="ctr"/>
+            <a:endParaRPr/>
           </a:p>
         </p:txBody>
       </p:sp>
@@ -8380,6 +8637,7 @@
                 <a:latin typeface="Consolas"/>
               </a:defRPr>
             </a:pPr>
+            <a:endParaRPr/>
           </a:p>
           <a:p>
             <a:pPr>
@@ -8457,7 +8715,7 @@
 </file>
 
 <file path=ppt/slides/slide3.xml><?xml version="1.0" encoding="utf-8"?>
-<p:sld xmlns:a="http://schemas.openxmlformats.org/drawingml/2006/main" xmlns:p="http://schemas.openxmlformats.org/presentationml/2006/main" xmlns:r="http://schemas.openxmlformats.org/officeDocument/2006/relationships">
+<p:sld xmlns:a="http://schemas.openxmlformats.org/drawingml/2006/main" xmlns:r="http://schemas.openxmlformats.org/officeDocument/2006/relationships" xmlns:p="http://schemas.openxmlformats.org/presentationml/2006/main">
   <p:cSld>
     <p:bg>
       <p:bgPr>
@@ -8473,7 +8731,14 @@
         <p:cNvGrpSpPr/>
         <p:nvPr/>
       </p:nvGrpSpPr>
-      <p:grpSpPr/>
+      <p:grpSpPr>
+        <a:xfrm>
+          <a:off x="0" y="0"/>
+          <a:ext cx="0" cy="0"/>
+          <a:chOff x="0" y="0"/>
+          <a:chExt cx="0" cy="0"/>
+        </a:xfrm>
+      </p:grpSpPr>
       <p:sp>
         <p:nvSpPr>
           <p:cNvPr id="2" name="Rectangle 1"/>
@@ -8514,6 +8779,7 @@
           <a:lstStyle/>
           <a:p>
             <a:pPr algn="ctr"/>
+            <a:endParaRPr/>
           </a:p>
         </p:txBody>
       </p:sp>
@@ -8561,7 +8827,7 @@
         <p:spPr>
           <a:xfrm>
             <a:off x="640080" y="1188720"/>
-            <a:ext cx="7863840" cy="5212080"/>
+            <a:ext cx="7863840" cy="2739211"/>
           </a:xfrm>
           <a:prstGeom prst="rect">
             <a:avLst/>
@@ -8585,6 +8851,7 @@
               </a:defRPr>
             </a:pPr>
             <a:r>
+              <a:rPr dirty="0"/>
               <a:t>Heap Tables: No clustered index</a:t>
             </a:r>
           </a:p>
@@ -8600,6 +8867,7 @@
               </a:defRPr>
             </a:pPr>
             <a:r>
+              <a:rPr dirty="0"/>
               <a:t>Fast inserts, slow reads</a:t>
             </a:r>
           </a:p>
@@ -8615,6 +8883,7 @@
               </a:defRPr>
             </a:pPr>
             <a:r>
+              <a:rPr dirty="0"/>
               <a:t>Best for staging tables, small lookup tables</a:t>
             </a:r>
           </a:p>
@@ -8630,8 +8899,54 @@
               </a:defRPr>
             </a:pPr>
             <a:r>
-              <a:t>B+-Tree: SQL Server's index implementation</a:t>
-            </a:r>
+              <a:rPr dirty="0"/>
+              <a:t>B-Tree: </a:t>
+            </a:r>
+            <a:r>
+              <a:rPr lang="en-US" dirty="0"/>
+              <a:t>Default </a:t>
+            </a:r>
+            <a:r>
+              <a:rPr lang="it-IT" dirty="0"/>
+              <a:t>index </a:t>
+            </a:r>
+            <a:r>
+              <a:rPr lang="it-IT" dirty="0" err="1"/>
+              <a:t>implementation</a:t>
+            </a:r>
+            <a:r>
+              <a:rPr lang="it-IT" dirty="0"/>
+              <a:t> for </a:t>
+            </a:r>
+            <a:r>
+              <a:rPr dirty="0"/>
+              <a:t>SQL Server</a:t>
+            </a:r>
+            <a:r>
+              <a:rPr lang="en-US" dirty="0"/>
+              <a:t> / PostgreSQL / Oracle / MongoDB</a:t>
+            </a:r>
+          </a:p>
+          <a:p>
+            <a:pPr>
+              <a:spcBef>
+                <a:spcPts val="600"/>
+              </a:spcBef>
+              <a:defRPr sz="1600">
+                <a:solidFill>
+                  <a:srgbClr val="424242"/>
+                </a:solidFill>
+              </a:defRPr>
+            </a:pPr>
+            <a:r>
+              <a:rPr lang="en-US" dirty="0" err="1"/>
+              <a:t>B+Tree</a:t>
+            </a:r>
+            <a:r>
+              <a:rPr lang="en-US" dirty="0"/>
+              <a:t>: Default index implementation for MySQL / MariaDB / DB2 / SQLite</a:t>
+            </a:r>
+            <a:endParaRPr dirty="0"/>
           </a:p>
           <a:p>
             <a:pPr lvl="1">
@@ -8645,6 +8960,7 @@
               </a:defRPr>
             </a:pPr>
             <a:r>
+              <a:rPr dirty="0"/>
               <a:t>All data stored in leaf nodes</a:t>
             </a:r>
           </a:p>
@@ -8660,6 +8976,7 @@
               </a:defRPr>
             </a:pPr>
             <a:r>
+              <a:rPr dirty="0"/>
               <a:t>3-4 levels for millions of rows</a:t>
             </a:r>
           </a:p>
@@ -8675,6 +8992,7 @@
               </a:defRPr>
             </a:pPr>
             <a:r>
+              <a:rPr dirty="0"/>
               <a:t>Efficient range scans via linked leaf nodes</a:t>
             </a:r>
           </a:p>
@@ -8690,6 +9008,7 @@
               </a:defRPr>
             </a:pPr>
             <a:r>
+              <a:rPr dirty="0"/>
               <a:t>Better cache utilization</a:t>
             </a:r>
           </a:p>
@@ -8704,7 +9023,7 @@
 </file>
 
 <file path=ppt/slides/slide30.xml><?xml version="1.0" encoding="utf-8"?>
-<p:sld xmlns:a="http://schemas.openxmlformats.org/drawingml/2006/main" xmlns:p="http://schemas.openxmlformats.org/presentationml/2006/main" xmlns:r="http://schemas.openxmlformats.org/officeDocument/2006/relationships">
+<p:sld xmlns:a="http://schemas.openxmlformats.org/drawingml/2006/main" xmlns:r="http://schemas.openxmlformats.org/officeDocument/2006/relationships" xmlns:p="http://schemas.openxmlformats.org/presentationml/2006/main">
   <p:cSld>
     <p:bg>
       <p:bgPr>
@@ -8720,7 +9039,14 @@
         <p:cNvGrpSpPr/>
         <p:nvPr/>
       </p:nvGrpSpPr>
-      <p:grpSpPr/>
+      <p:grpSpPr>
+        <a:xfrm>
+          <a:off x="0" y="0"/>
+          <a:ext cx="0" cy="0"/>
+          <a:chOff x="0" y="0"/>
+          <a:chExt cx="0" cy="0"/>
+        </a:xfrm>
+      </p:grpSpPr>
       <p:sp>
         <p:nvSpPr>
           <p:cNvPr id="2" name="Rectangle 1"/>
@@ -8761,6 +9087,7 @@
           <a:lstStyle/>
           <a:p>
             <a:pPr algn="ctr"/>
+            <a:endParaRPr/>
           </a:p>
         </p:txBody>
       </p:sp>
@@ -8921,7 +9248,7 @@
 </file>
 
 <file path=ppt/slides/slide31.xml><?xml version="1.0" encoding="utf-8"?>
-<p:sld xmlns:a="http://schemas.openxmlformats.org/drawingml/2006/main" xmlns:p="http://schemas.openxmlformats.org/presentationml/2006/main" xmlns:r="http://schemas.openxmlformats.org/officeDocument/2006/relationships">
+<p:sld xmlns:a="http://schemas.openxmlformats.org/drawingml/2006/main" xmlns:r="http://schemas.openxmlformats.org/officeDocument/2006/relationships" xmlns:p="http://schemas.openxmlformats.org/presentationml/2006/main">
   <p:cSld>
     <p:bg>
       <p:bgPr>
@@ -8937,7 +9264,14 @@
         <p:cNvGrpSpPr/>
         <p:nvPr/>
       </p:nvGrpSpPr>
-      <p:grpSpPr/>
+      <p:grpSpPr>
+        <a:xfrm>
+          <a:off x="0" y="0"/>
+          <a:ext cx="0" cy="0"/>
+          <a:chOff x="0" y="0"/>
+          <a:chExt cx="0" cy="0"/>
+        </a:xfrm>
+      </p:grpSpPr>
       <p:sp>
         <p:nvSpPr>
           <p:cNvPr id="2" name="Rectangle 1"/>
@@ -8978,6 +9312,7 @@
           <a:lstStyle/>
           <a:p>
             <a:pPr algn="ctr"/>
+            <a:endParaRPr/>
           </a:p>
         </p:txBody>
       </p:sp>
@@ -9123,6 +9458,7 @@
                 </a:solidFill>
               </a:defRPr>
             </a:pPr>
+            <a:endParaRPr/>
           </a:p>
           <a:p>
             <a:pPr>
@@ -9210,7 +9546,7 @@
 </file>
 
 <file path=ppt/slides/slide32.xml><?xml version="1.0" encoding="utf-8"?>
-<p:sld xmlns:a="http://schemas.openxmlformats.org/drawingml/2006/main" xmlns:p="http://schemas.openxmlformats.org/presentationml/2006/main" xmlns:r="http://schemas.openxmlformats.org/officeDocument/2006/relationships">
+<p:sld xmlns:a="http://schemas.openxmlformats.org/drawingml/2006/main" xmlns:r="http://schemas.openxmlformats.org/officeDocument/2006/relationships" xmlns:p="http://schemas.openxmlformats.org/presentationml/2006/main">
   <p:cSld>
     <p:bg>
       <p:bgPr>
@@ -9226,7 +9562,14 @@
         <p:cNvGrpSpPr/>
         <p:nvPr/>
       </p:nvGrpSpPr>
-      <p:grpSpPr/>
+      <p:grpSpPr>
+        <a:xfrm>
+          <a:off x="0" y="0"/>
+          <a:ext cx="0" cy="0"/>
+          <a:chOff x="0" y="0"/>
+          <a:chExt cx="0" cy="0"/>
+        </a:xfrm>
+      </p:grpSpPr>
       <p:sp>
         <p:nvSpPr>
           <p:cNvPr id="2" name="Rectangle 1"/>
@@ -9267,6 +9610,7 @@
           <a:lstStyle/>
           <a:p>
             <a:pPr algn="ctr"/>
+            <a:endParaRPr/>
           </a:p>
         </p:txBody>
       </p:sp>
@@ -9489,6 +9833,7 @@
                 <a:latin typeface="Consolas"/>
               </a:defRPr>
             </a:pPr>
+            <a:endParaRPr/>
           </a:p>
           <a:p>
             <a:pPr>
@@ -9527,7 +9872,7 @@
 </file>
 
 <file path=ppt/slides/slide33.xml><?xml version="1.0" encoding="utf-8"?>
-<p:sld xmlns:a="http://schemas.openxmlformats.org/drawingml/2006/main" xmlns:p="http://schemas.openxmlformats.org/presentationml/2006/main" xmlns:r="http://schemas.openxmlformats.org/officeDocument/2006/relationships">
+<p:sld xmlns:a="http://schemas.openxmlformats.org/drawingml/2006/main" xmlns:r="http://schemas.openxmlformats.org/officeDocument/2006/relationships" xmlns:p="http://schemas.openxmlformats.org/presentationml/2006/main">
   <p:cSld>
     <p:bg>
       <p:bgPr>
@@ -9543,7 +9888,14 @@
         <p:cNvGrpSpPr/>
         <p:nvPr/>
       </p:nvGrpSpPr>
-      <p:grpSpPr/>
+      <p:grpSpPr>
+        <a:xfrm>
+          <a:off x="0" y="0"/>
+          <a:ext cx="0" cy="0"/>
+          <a:chOff x="0" y="0"/>
+          <a:chExt cx="0" cy="0"/>
+        </a:xfrm>
+      </p:grpSpPr>
       <p:sp>
         <p:nvSpPr>
           <p:cNvPr id="2" name="Rectangle 1"/>
@@ -9584,6 +9936,7 @@
           <a:lstStyle/>
           <a:p>
             <a:pPr algn="ctr"/>
+            <a:endParaRPr/>
           </a:p>
         </p:txBody>
       </p:sp>
@@ -9744,7 +10097,7 @@
 </file>
 
 <file path=ppt/slides/slide34.xml><?xml version="1.0" encoding="utf-8"?>
-<p:sld xmlns:a="http://schemas.openxmlformats.org/drawingml/2006/main" xmlns:p="http://schemas.openxmlformats.org/presentationml/2006/main" xmlns:r="http://schemas.openxmlformats.org/officeDocument/2006/relationships">
+<p:sld xmlns:a="http://schemas.openxmlformats.org/drawingml/2006/main" xmlns:r="http://schemas.openxmlformats.org/officeDocument/2006/relationships" xmlns:p="http://schemas.openxmlformats.org/presentationml/2006/main">
   <p:cSld>
     <p:bg>
       <p:bgPr>
@@ -9760,7 +10113,14 @@
         <p:cNvGrpSpPr/>
         <p:nvPr/>
       </p:nvGrpSpPr>
-      <p:grpSpPr/>
+      <p:grpSpPr>
+        <a:xfrm>
+          <a:off x="0" y="0"/>
+          <a:ext cx="0" cy="0"/>
+          <a:chOff x="0" y="0"/>
+          <a:chExt cx="0" cy="0"/>
+        </a:xfrm>
+      </p:grpSpPr>
       <p:sp>
         <p:nvSpPr>
           <p:cNvPr id="2" name="Rectangle 1"/>
@@ -9801,6 +10161,7 @@
           <a:lstStyle/>
           <a:p>
             <a:pPr algn="ctr"/>
+            <a:endParaRPr/>
           </a:p>
         </p:txBody>
       </p:sp>
@@ -9916,6 +10277,7 @@
                 </a:solidFill>
               </a:defRPr>
             </a:pPr>
+            <a:endParaRPr/>
           </a:p>
           <a:p>
             <a:pPr>
@@ -9958,6 +10320,7 @@
                 </a:solidFill>
               </a:defRPr>
             </a:pPr>
+            <a:endParaRPr/>
           </a:p>
           <a:p>
             <a:pPr>
@@ -10015,7 +10378,7 @@
 </file>
 
 <file path=ppt/slides/slide35.xml><?xml version="1.0" encoding="utf-8"?>
-<p:sld xmlns:a="http://schemas.openxmlformats.org/drawingml/2006/main" xmlns:p="http://schemas.openxmlformats.org/presentationml/2006/main" xmlns:r="http://schemas.openxmlformats.org/officeDocument/2006/relationships">
+<p:sld xmlns:a="http://schemas.openxmlformats.org/drawingml/2006/main" xmlns:r="http://schemas.openxmlformats.org/officeDocument/2006/relationships" xmlns:p="http://schemas.openxmlformats.org/presentationml/2006/main">
   <p:cSld>
     <p:bg>
       <p:bgPr>
@@ -10031,7 +10394,14 @@
         <p:cNvGrpSpPr/>
         <p:nvPr/>
       </p:nvGrpSpPr>
-      <p:grpSpPr/>
+      <p:grpSpPr>
+        <a:xfrm>
+          <a:off x="0" y="0"/>
+          <a:ext cx="0" cy="0"/>
+          <a:chOff x="0" y="0"/>
+          <a:chExt cx="0" cy="0"/>
+        </a:xfrm>
+      </p:grpSpPr>
       <p:sp>
         <p:nvSpPr>
           <p:cNvPr id="2" name="Rectangle 1"/>
@@ -10072,6 +10442,7 @@
           <a:lstStyle/>
           <a:p>
             <a:pPr algn="ctr"/>
+            <a:endParaRPr/>
           </a:p>
         </p:txBody>
       </p:sp>
@@ -10202,6 +10573,7 @@
                 </a:solidFill>
               </a:defRPr>
             </a:pPr>
+            <a:endParaRPr/>
           </a:p>
           <a:p>
             <a:pPr>
@@ -10274,7 +10646,7 @@
 </file>
 
 <file path=ppt/slides/slide36.xml><?xml version="1.0" encoding="utf-8"?>
-<p:sld xmlns:a="http://schemas.openxmlformats.org/drawingml/2006/main" xmlns:p="http://schemas.openxmlformats.org/presentationml/2006/main" xmlns:r="http://schemas.openxmlformats.org/officeDocument/2006/relationships">
+<p:sld xmlns:a="http://schemas.openxmlformats.org/drawingml/2006/main" xmlns:r="http://schemas.openxmlformats.org/officeDocument/2006/relationships" xmlns:p="http://schemas.openxmlformats.org/presentationml/2006/main">
   <p:cSld>
     <p:bg>
       <p:bgPr>
@@ -10290,7 +10662,14 @@
         <p:cNvGrpSpPr/>
         <p:nvPr/>
       </p:nvGrpSpPr>
-      <p:grpSpPr/>
+      <p:grpSpPr>
+        <a:xfrm>
+          <a:off x="0" y="0"/>
+          <a:ext cx="0" cy="0"/>
+          <a:chOff x="0" y="0"/>
+          <a:chExt cx="0" cy="0"/>
+        </a:xfrm>
+      </p:grpSpPr>
       <p:sp>
         <p:nvSpPr>
           <p:cNvPr id="2" name="Rectangle 1"/>
@@ -10331,6 +10710,7 @@
           <a:lstStyle/>
           <a:p>
             <a:pPr algn="ctr"/>
+            <a:endParaRPr/>
           </a:p>
         </p:txBody>
       </p:sp>
@@ -10475,6 +10855,7 @@
                 <a:latin typeface="Consolas"/>
               </a:defRPr>
             </a:pPr>
+            <a:endParaRPr/>
           </a:p>
           <a:p>
             <a:pPr>
@@ -10526,7 +10907,7 @@
 </file>
 
 <file path=ppt/slides/slide37.xml><?xml version="1.0" encoding="utf-8"?>
-<p:sld xmlns:a="http://schemas.openxmlformats.org/drawingml/2006/main" xmlns:p="http://schemas.openxmlformats.org/presentationml/2006/main" xmlns:r="http://schemas.openxmlformats.org/officeDocument/2006/relationships">
+<p:sld xmlns:a="http://schemas.openxmlformats.org/drawingml/2006/main" xmlns:r="http://schemas.openxmlformats.org/officeDocument/2006/relationships" xmlns:p="http://schemas.openxmlformats.org/presentationml/2006/main">
   <p:cSld>
     <p:bg>
       <p:bgPr>
@@ -10542,7 +10923,14 @@
         <p:cNvGrpSpPr/>
         <p:nvPr/>
       </p:nvGrpSpPr>
-      <p:grpSpPr/>
+      <p:grpSpPr>
+        <a:xfrm>
+          <a:off x="0" y="0"/>
+          <a:ext cx="0" cy="0"/>
+          <a:chOff x="0" y="0"/>
+          <a:chExt cx="0" cy="0"/>
+        </a:xfrm>
+      </p:grpSpPr>
       <p:sp>
         <p:nvSpPr>
           <p:cNvPr id="2" name="Rectangle 1"/>
@@ -10583,6 +10971,7 @@
           <a:lstStyle/>
           <a:p>
             <a:pPr algn="ctr"/>
+            <a:endParaRPr/>
           </a:p>
         </p:txBody>
       </p:sp>
@@ -10654,6 +11043,7 @@
               </a:defRPr>
             </a:pPr>
             <a:r>
+              <a:rPr dirty="0"/>
               <a:t>3. RECOMPILE</a:t>
             </a:r>
           </a:p>
@@ -10669,6 +11059,7 @@
               </a:defRPr>
             </a:pPr>
             <a:r>
+              <a:rPr dirty="0"/>
               <a:t>WITH RECOMPILE or OPTION (RECOMPILE)</a:t>
             </a:r>
           </a:p>
@@ -10684,6 +11075,7 @@
               </a:defRPr>
             </a:pPr>
             <a:r>
+              <a:rPr dirty="0"/>
               <a:t>Use: High sensitivity, low frequency</a:t>
             </a:r>
           </a:p>
@@ -10698,6 +11090,7 @@
                 </a:solidFill>
               </a:defRPr>
             </a:pPr>
+            <a:endParaRPr dirty="0"/>
           </a:p>
           <a:p>
             <a:pPr>
@@ -10711,6 +11104,7 @@
               </a:defRPr>
             </a:pPr>
             <a:r>
+              <a:rPr dirty="0"/>
               <a:t>4. Local variable copy</a:t>
             </a:r>
           </a:p>
@@ -10726,6 +11120,7 @@
               </a:defRPr>
             </a:pPr>
             <a:r>
+              <a:rPr dirty="0"/>
               <a:t>DECLARE @Local = @Parameter</a:t>
             </a:r>
           </a:p>
@@ -10740,6 +11135,7 @@
                 </a:solidFill>
               </a:defRPr>
             </a:pPr>
+            <a:endParaRPr dirty="0"/>
           </a:p>
           <a:p>
             <a:pPr>
@@ -10753,6 +11149,7 @@
               </a:defRPr>
             </a:pPr>
             <a:r>
+              <a:rPr dirty="0"/>
               <a:t>5. Dynamic SQL (fresh plan each time)</a:t>
             </a:r>
           </a:p>
@@ -10768,6 +11165,7 @@
               </a:defRPr>
             </a:pPr>
             <a:r>
+              <a:rPr dirty="0"/>
               <a:t>6. Multiple procedures (branch logic)</a:t>
             </a:r>
           </a:p>
@@ -10783,6 +11181,7 @@
               </a:defRPr>
             </a:pPr>
             <a:r>
+              <a:rPr dirty="0"/>
               <a:t>7. SQL 2022: Parameter Sensitive Plans (PSP) - Automatic!</a:t>
             </a:r>
           </a:p>
@@ -10797,7 +11196,7 @@
 </file>
 
 <file path=ppt/slides/slide38.xml><?xml version="1.0" encoding="utf-8"?>
-<p:sld xmlns:a="http://schemas.openxmlformats.org/drawingml/2006/main" xmlns:p="http://schemas.openxmlformats.org/presentationml/2006/main" xmlns:r="http://schemas.openxmlformats.org/officeDocument/2006/relationships">
+<p:sld xmlns:a="http://schemas.openxmlformats.org/drawingml/2006/main" xmlns:r="http://schemas.openxmlformats.org/officeDocument/2006/relationships" xmlns:p="http://schemas.openxmlformats.org/presentationml/2006/main">
   <p:cSld>
     <p:bg>
       <p:bgPr>
@@ -10813,7 +11212,14 @@
         <p:cNvGrpSpPr/>
         <p:nvPr/>
       </p:nvGrpSpPr>
-      <p:grpSpPr/>
+      <p:grpSpPr>
+        <a:xfrm>
+          <a:off x="0" y="0"/>
+          <a:ext cx="0" cy="0"/>
+          <a:chOff x="0" y="0"/>
+          <a:chExt cx="0" cy="0"/>
+        </a:xfrm>
+      </p:grpSpPr>
       <p:sp>
         <p:nvSpPr>
           <p:cNvPr id="2" name="Rectangle 1"/>
@@ -10854,6 +11260,7 @@
           <a:lstStyle/>
           <a:p>
             <a:pPr algn="ctr"/>
+            <a:endParaRPr/>
           </a:p>
         </p:txBody>
       </p:sp>
@@ -10925,6 +11332,7 @@
               </a:defRPr>
             </a:pPr>
             <a:r>
+              <a:rPr dirty="0"/>
               <a:t>Decision Matrix:</a:t>
             </a:r>
           </a:p>
@@ -10940,6 +11348,7 @@
               </a:defRPr>
             </a:pPr>
             <a:r>
+              <a:rPr dirty="0"/>
               <a:t>One value dominates (90%+) → OPTIMIZE FOR value</a:t>
             </a:r>
           </a:p>
@@ -10955,6 +11364,7 @@
               </a:defRPr>
             </a:pPr>
             <a:r>
+              <a:rPr dirty="0"/>
               <a:t>Even distribution → OPTIMIZE FOR UNKNOWN</a:t>
             </a:r>
           </a:p>
@@ -10970,6 +11380,7 @@
               </a:defRPr>
             </a:pPr>
             <a:r>
+              <a:rPr dirty="0"/>
               <a:t>Extreme sensitivity → RECOMPILE</a:t>
             </a:r>
           </a:p>
@@ -10985,6 +11396,7 @@
               </a:defRPr>
             </a:pPr>
             <a:r>
+              <a:rPr dirty="0"/>
               <a:t>Ad-hoc reporting → Dynamic SQL</a:t>
             </a:r>
           </a:p>
@@ -11000,6 +11412,7 @@
               </a:defRPr>
             </a:pPr>
             <a:r>
+              <a:rPr dirty="0"/>
               <a:t>SQL Server 2022+ → Enable PSP</a:t>
             </a:r>
           </a:p>
@@ -11014,6 +11427,7 @@
                 </a:solidFill>
               </a:defRPr>
             </a:pPr>
+            <a:endParaRPr dirty="0"/>
           </a:p>
           <a:p>
             <a:pPr>
@@ -11027,6 +11441,7 @@
               </a:defRPr>
             </a:pPr>
             <a:r>
+              <a:rPr dirty="0"/>
               <a:t>SQL 2022 PSP: Automatically detects and creates multiple plans!</a:t>
             </a:r>
           </a:p>
@@ -11041,7 +11456,7 @@
 </file>
 
 <file path=ppt/slides/slide39.xml><?xml version="1.0" encoding="utf-8"?>
-<p:sld xmlns:a="http://schemas.openxmlformats.org/drawingml/2006/main" xmlns:p="http://schemas.openxmlformats.org/presentationml/2006/main" xmlns:r="http://schemas.openxmlformats.org/officeDocument/2006/relationships">
+<p:sld xmlns:a="http://schemas.openxmlformats.org/drawingml/2006/main" xmlns:r="http://schemas.openxmlformats.org/officeDocument/2006/relationships" xmlns:p="http://schemas.openxmlformats.org/presentationml/2006/main">
   <p:cSld>
     <p:bg>
       <p:bgPr>
@@ -11057,7 +11472,14 @@
         <p:cNvGrpSpPr/>
         <p:nvPr/>
       </p:nvGrpSpPr>
-      <p:grpSpPr/>
+      <p:grpSpPr>
+        <a:xfrm>
+          <a:off x="0" y="0"/>
+          <a:ext cx="0" cy="0"/>
+          <a:chOff x="0" y="0"/>
+          <a:chExt cx="0" cy="0"/>
+        </a:xfrm>
+      </p:grpSpPr>
       <p:sp>
         <p:nvSpPr>
           <p:cNvPr id="2" name="Rectangle 1"/>
@@ -11098,6 +11520,7 @@
           <a:lstStyle/>
           <a:p>
             <a:pPr algn="ctr"/>
+            <a:endParaRPr/>
           </a:p>
         </p:txBody>
       </p:sp>
@@ -11258,7 +11681,7 @@
 </file>
 
 <file path=ppt/slides/slide4.xml><?xml version="1.0" encoding="utf-8"?>
-<p:sld xmlns:a="http://schemas.openxmlformats.org/drawingml/2006/main" xmlns:p="http://schemas.openxmlformats.org/presentationml/2006/main" xmlns:r="http://schemas.openxmlformats.org/officeDocument/2006/relationships">
+<p:sld xmlns:a="http://schemas.openxmlformats.org/drawingml/2006/main" xmlns:r="http://schemas.openxmlformats.org/officeDocument/2006/relationships" xmlns:p="http://schemas.openxmlformats.org/presentationml/2006/main">
   <p:cSld>
     <p:bg>
       <p:bgPr>
@@ -11274,7 +11697,14 @@
         <p:cNvGrpSpPr/>
         <p:nvPr/>
       </p:nvGrpSpPr>
-      <p:grpSpPr/>
+      <p:grpSpPr>
+        <a:xfrm>
+          <a:off x="0" y="0"/>
+          <a:ext cx="0" cy="0"/>
+          <a:chOff x="0" y="0"/>
+          <a:chExt cx="0" cy="0"/>
+        </a:xfrm>
+      </p:grpSpPr>
       <p:sp>
         <p:nvSpPr>
           <p:cNvPr id="2" name="Rectangle 1"/>
@@ -11315,6 +11745,7 @@
           <a:lstStyle/>
           <a:p>
             <a:pPr algn="ctr"/>
+            <a:endParaRPr/>
           </a:p>
         </p:txBody>
       </p:sp>
@@ -11445,6 +11876,7 @@
                 </a:solidFill>
               </a:defRPr>
             </a:pPr>
+            <a:endParaRPr/>
           </a:p>
           <a:p>
             <a:pPr>
@@ -11517,7 +11949,7 @@
 </file>
 
 <file path=ppt/slides/slide40.xml><?xml version="1.0" encoding="utf-8"?>
-<p:sld xmlns:a="http://schemas.openxmlformats.org/drawingml/2006/main" xmlns:p="http://schemas.openxmlformats.org/presentationml/2006/main" xmlns:r="http://schemas.openxmlformats.org/officeDocument/2006/relationships">
+<p:sld xmlns:a="http://schemas.openxmlformats.org/drawingml/2006/main" xmlns:r="http://schemas.openxmlformats.org/officeDocument/2006/relationships" xmlns:p="http://schemas.openxmlformats.org/presentationml/2006/main">
   <p:cSld>
     <p:bg>
       <p:bgPr>
@@ -11533,7 +11965,14 @@
         <p:cNvGrpSpPr/>
         <p:nvPr/>
       </p:nvGrpSpPr>
-      <p:grpSpPr/>
+      <p:grpSpPr>
+        <a:xfrm>
+          <a:off x="0" y="0"/>
+          <a:ext cx="0" cy="0"/>
+          <a:chOff x="0" y="0"/>
+          <a:chExt cx="0" cy="0"/>
+        </a:xfrm>
+      </p:grpSpPr>
       <p:sp>
         <p:nvSpPr>
           <p:cNvPr id="2" name="Rectangle 1"/>
@@ -11574,6 +12013,7 @@
           <a:lstStyle/>
           <a:p>
             <a:pPr algn="ctr"/>
+            <a:endParaRPr/>
           </a:p>
         </p:txBody>
       </p:sp>
@@ -11734,6 +12174,7 @@
                 </a:solidFill>
               </a:defRPr>
             </a:pPr>
+            <a:endParaRPr/>
           </a:p>
           <a:p>
             <a:pPr>
@@ -11806,7 +12247,7 @@
 </file>
 
 <file path=ppt/slides/slide41.xml><?xml version="1.0" encoding="utf-8"?>
-<p:sld xmlns:a="http://schemas.openxmlformats.org/drawingml/2006/main" xmlns:p="http://schemas.openxmlformats.org/presentationml/2006/main" xmlns:r="http://schemas.openxmlformats.org/officeDocument/2006/relationships">
+<p:sld xmlns:a="http://schemas.openxmlformats.org/drawingml/2006/main" xmlns:r="http://schemas.openxmlformats.org/officeDocument/2006/relationships" xmlns:p="http://schemas.openxmlformats.org/presentationml/2006/main">
   <p:cSld>
     <p:bg>
       <p:bgPr>
@@ -11822,7 +12263,14 @@
         <p:cNvGrpSpPr/>
         <p:nvPr/>
       </p:nvGrpSpPr>
-      <p:grpSpPr/>
+      <p:grpSpPr>
+        <a:xfrm>
+          <a:off x="0" y="0"/>
+          <a:ext cx="0" cy="0"/>
+          <a:chOff x="0" y="0"/>
+          <a:chExt cx="0" cy="0"/>
+        </a:xfrm>
+      </p:grpSpPr>
       <p:sp>
         <p:nvSpPr>
           <p:cNvPr id="2" name="Rectangle 1"/>
@@ -11863,6 +12311,7 @@
           <a:lstStyle/>
           <a:p>
             <a:pPr algn="ctr"/>
+            <a:endParaRPr/>
           </a:p>
         </p:txBody>
       </p:sp>
@@ -12038,7 +12487,7 @@
 </file>
 
 <file path=ppt/slides/slide42.xml><?xml version="1.0" encoding="utf-8"?>
-<p:sld xmlns:a="http://schemas.openxmlformats.org/drawingml/2006/main" xmlns:p="http://schemas.openxmlformats.org/presentationml/2006/main" xmlns:r="http://schemas.openxmlformats.org/officeDocument/2006/relationships">
+<p:sld xmlns:a="http://schemas.openxmlformats.org/drawingml/2006/main" xmlns:r="http://schemas.openxmlformats.org/officeDocument/2006/relationships" xmlns:p="http://schemas.openxmlformats.org/presentationml/2006/main">
   <p:cSld>
     <p:bg>
       <p:bgPr>
@@ -12054,7 +12503,14 @@
         <p:cNvGrpSpPr/>
         <p:nvPr/>
       </p:nvGrpSpPr>
-      <p:grpSpPr/>
+      <p:grpSpPr>
+        <a:xfrm>
+          <a:off x="0" y="0"/>
+          <a:ext cx="0" cy="0"/>
+          <a:chOff x="0" y="0"/>
+          <a:chExt cx="0" cy="0"/>
+        </a:xfrm>
+      </p:grpSpPr>
       <p:sp>
         <p:nvSpPr>
           <p:cNvPr id="2" name="Rectangle 1"/>
@@ -12095,6 +12551,7 @@
           <a:lstStyle/>
           <a:p>
             <a:pPr algn="ctr"/>
+            <a:endParaRPr/>
           </a:p>
         </p:txBody>
       </p:sp>
@@ -12285,7 +12742,7 @@
 </file>
 
 <file path=ppt/slides/slide43.xml><?xml version="1.0" encoding="utf-8"?>
-<p:sld xmlns:a="http://schemas.openxmlformats.org/drawingml/2006/main" xmlns:p="http://schemas.openxmlformats.org/presentationml/2006/main" xmlns:r="http://schemas.openxmlformats.org/officeDocument/2006/relationships">
+<p:sld xmlns:a="http://schemas.openxmlformats.org/drawingml/2006/main" xmlns:r="http://schemas.openxmlformats.org/officeDocument/2006/relationships" xmlns:p="http://schemas.openxmlformats.org/presentationml/2006/main">
   <p:cSld>
     <p:bg>
       <p:bgPr>
@@ -12301,7 +12758,14 @@
         <p:cNvGrpSpPr/>
         <p:nvPr/>
       </p:nvGrpSpPr>
-      <p:grpSpPr/>
+      <p:grpSpPr>
+        <a:xfrm>
+          <a:off x="0" y="0"/>
+          <a:ext cx="0" cy="0"/>
+          <a:chOff x="0" y="0"/>
+          <a:chExt cx="0" cy="0"/>
+        </a:xfrm>
+      </p:grpSpPr>
       <p:sp>
         <p:nvSpPr>
           <p:cNvPr id="2" name="Rectangle 1"/>
@@ -12342,6 +12806,7 @@
           <a:lstStyle/>
           <a:p>
             <a:pPr algn="ctr"/>
+            <a:endParaRPr/>
           </a:p>
         </p:txBody>
       </p:sp>
@@ -12487,6 +12952,7 @@
                 </a:solidFill>
               </a:defRPr>
             </a:pPr>
+            <a:endParaRPr/>
           </a:p>
           <a:p>
             <a:pPr>
@@ -12559,7 +13025,7 @@
 </file>
 
 <file path=ppt/slides/slide44.xml><?xml version="1.0" encoding="utf-8"?>
-<p:sld xmlns:a="http://schemas.openxmlformats.org/drawingml/2006/main" xmlns:p="http://schemas.openxmlformats.org/presentationml/2006/main" xmlns:r="http://schemas.openxmlformats.org/officeDocument/2006/relationships">
+<p:sld xmlns:a="http://schemas.openxmlformats.org/drawingml/2006/main" xmlns:r="http://schemas.openxmlformats.org/officeDocument/2006/relationships" xmlns:p="http://schemas.openxmlformats.org/presentationml/2006/main">
   <p:cSld>
     <p:bg>
       <p:bgPr>
@@ -12575,7 +13041,14 @@
         <p:cNvGrpSpPr/>
         <p:nvPr/>
       </p:nvGrpSpPr>
-      <p:grpSpPr/>
+      <p:grpSpPr>
+        <a:xfrm>
+          <a:off x="0" y="0"/>
+          <a:ext cx="0" cy="0"/>
+          <a:chOff x="0" y="0"/>
+          <a:chExt cx="0" cy="0"/>
+        </a:xfrm>
+      </p:grpSpPr>
       <p:sp>
         <p:nvSpPr>
           <p:cNvPr id="2" name="Rectangle 1"/>
@@ -12616,6 +13089,7 @@
           <a:lstStyle/>
           <a:p>
             <a:pPr algn="ctr"/>
+            <a:endParaRPr/>
           </a:p>
         </p:txBody>
       </p:sp>
@@ -12776,6 +13250,7 @@
                 </a:solidFill>
               </a:defRPr>
             </a:pPr>
+            <a:endParaRPr/>
           </a:p>
           <a:p>
             <a:pPr>
@@ -12818,7 +13293,7 @@
 </file>
 
 <file path=ppt/slides/slide45.xml><?xml version="1.0" encoding="utf-8"?>
-<p:sld xmlns:a="http://schemas.openxmlformats.org/drawingml/2006/main" xmlns:p="http://schemas.openxmlformats.org/presentationml/2006/main" xmlns:r="http://schemas.openxmlformats.org/officeDocument/2006/relationships">
+<p:sld xmlns:a="http://schemas.openxmlformats.org/drawingml/2006/main" xmlns:r="http://schemas.openxmlformats.org/officeDocument/2006/relationships" xmlns:p="http://schemas.openxmlformats.org/presentationml/2006/main">
   <p:cSld>
     <p:bg>
       <p:bgPr>
@@ -12834,7 +13309,14 @@
         <p:cNvGrpSpPr/>
         <p:nvPr/>
       </p:nvGrpSpPr>
-      <p:grpSpPr/>
+      <p:grpSpPr>
+        <a:xfrm>
+          <a:off x="0" y="0"/>
+          <a:ext cx="0" cy="0"/>
+          <a:chOff x="0" y="0"/>
+          <a:chExt cx="0" cy="0"/>
+        </a:xfrm>
+      </p:grpSpPr>
       <p:sp>
         <p:nvSpPr>
           <p:cNvPr id="2" name="TextBox 1"/>
@@ -12914,7 +13396,7 @@
 </file>
 
 <file path=ppt/slides/slide46.xml><?xml version="1.0" encoding="utf-8"?>
-<p:sld xmlns:a="http://schemas.openxmlformats.org/drawingml/2006/main" xmlns:p="http://schemas.openxmlformats.org/presentationml/2006/main" xmlns:r="http://schemas.openxmlformats.org/officeDocument/2006/relationships">
+<p:sld xmlns:a="http://schemas.openxmlformats.org/drawingml/2006/main" xmlns:r="http://schemas.openxmlformats.org/officeDocument/2006/relationships" xmlns:p="http://schemas.openxmlformats.org/presentationml/2006/main">
   <p:cSld>
     <p:bg>
       <p:bgPr>
@@ -12930,7 +13412,14 @@
         <p:cNvGrpSpPr/>
         <p:nvPr/>
       </p:nvGrpSpPr>
-      <p:grpSpPr/>
+      <p:grpSpPr>
+        <a:xfrm>
+          <a:off x="0" y="0"/>
+          <a:ext cx="0" cy="0"/>
+          <a:chOff x="0" y="0"/>
+          <a:chExt cx="0" cy="0"/>
+        </a:xfrm>
+      </p:grpSpPr>
       <p:sp>
         <p:nvSpPr>
           <p:cNvPr id="2" name="TextBox 1"/>
@@ -13019,6 +13508,7 @@
                 </a:solidFill>
               </a:defRPr>
             </a:pPr>
+            <a:endParaRPr/>
           </a:p>
           <a:p>
             <a:pPr algn="ctr">
@@ -13043,7 +13533,7 @@
 </file>
 
 <file path=ppt/slides/slide5.xml><?xml version="1.0" encoding="utf-8"?>
-<p:sld xmlns:a="http://schemas.openxmlformats.org/drawingml/2006/main" xmlns:p="http://schemas.openxmlformats.org/presentationml/2006/main" xmlns:r="http://schemas.openxmlformats.org/officeDocument/2006/relationships">
+<p:sld xmlns:a="http://schemas.openxmlformats.org/drawingml/2006/main" xmlns:r="http://schemas.openxmlformats.org/officeDocument/2006/relationships" xmlns:p="http://schemas.openxmlformats.org/presentationml/2006/main">
   <p:cSld>
     <p:bg>
       <p:bgPr>
@@ -13059,7 +13549,14 @@
         <p:cNvGrpSpPr/>
         <p:nvPr/>
       </p:nvGrpSpPr>
-      <p:grpSpPr/>
+      <p:grpSpPr>
+        <a:xfrm>
+          <a:off x="0" y="0"/>
+          <a:ext cx="0" cy="0"/>
+          <a:chOff x="0" y="0"/>
+          <a:chExt cx="0" cy="0"/>
+        </a:xfrm>
+      </p:grpSpPr>
       <p:sp>
         <p:nvSpPr>
           <p:cNvPr id="2" name="Rectangle 1"/>
@@ -13100,6 +13597,7 @@
           <a:lstStyle/>
           <a:p>
             <a:pPr algn="ctr"/>
+            <a:endParaRPr/>
           </a:p>
         </p:txBody>
       </p:sp>
@@ -13245,6 +13743,7 @@
                 </a:solidFill>
               </a:defRPr>
             </a:pPr>
+            <a:endParaRPr/>
           </a:p>
           <a:p>
             <a:pPr>
@@ -13302,7 +13801,7 @@
 </file>
 
 <file path=ppt/slides/slide6.xml><?xml version="1.0" encoding="utf-8"?>
-<p:sld xmlns:a="http://schemas.openxmlformats.org/drawingml/2006/main" xmlns:p="http://schemas.openxmlformats.org/presentationml/2006/main" xmlns:r="http://schemas.openxmlformats.org/officeDocument/2006/relationships">
+<p:sld xmlns:a="http://schemas.openxmlformats.org/drawingml/2006/main" xmlns:r="http://schemas.openxmlformats.org/officeDocument/2006/relationships" xmlns:p="http://schemas.openxmlformats.org/presentationml/2006/main">
   <p:cSld>
     <p:bg>
       <p:bgPr>
@@ -13318,7 +13817,14 @@
         <p:cNvGrpSpPr/>
         <p:nvPr/>
       </p:nvGrpSpPr>
-      <p:grpSpPr/>
+      <p:grpSpPr>
+        <a:xfrm>
+          <a:off x="0" y="0"/>
+          <a:ext cx="0" cy="0"/>
+          <a:chOff x="0" y="0"/>
+          <a:chExt cx="0" cy="0"/>
+        </a:xfrm>
+      </p:grpSpPr>
       <p:sp>
         <p:nvSpPr>
           <p:cNvPr id="2" name="Rectangle 1"/>
@@ -13359,6 +13865,7 @@
           <a:lstStyle/>
           <a:p>
             <a:pPr algn="ctr"/>
+            <a:endParaRPr/>
           </a:p>
         </p:txBody>
       </p:sp>
@@ -13489,6 +13996,7 @@
                 </a:solidFill>
               </a:defRPr>
             </a:pPr>
+            <a:endParaRPr/>
           </a:p>
           <a:p>
             <a:pPr>
@@ -13531,7 +14039,7 @@
 </file>
 
 <file path=ppt/slides/slide7.xml><?xml version="1.0" encoding="utf-8"?>
-<p:sld xmlns:a="http://schemas.openxmlformats.org/drawingml/2006/main" xmlns:p="http://schemas.openxmlformats.org/presentationml/2006/main" xmlns:r="http://schemas.openxmlformats.org/officeDocument/2006/relationships">
+<p:sld xmlns:a="http://schemas.openxmlformats.org/drawingml/2006/main" xmlns:r="http://schemas.openxmlformats.org/officeDocument/2006/relationships" xmlns:p="http://schemas.openxmlformats.org/presentationml/2006/main">
   <p:cSld>
     <p:bg>
       <p:bgPr>
@@ -13547,7 +14055,14 @@
         <p:cNvGrpSpPr/>
         <p:nvPr/>
       </p:nvGrpSpPr>
-      <p:grpSpPr/>
+      <p:grpSpPr>
+        <a:xfrm>
+          <a:off x="0" y="0"/>
+          <a:ext cx="0" cy="0"/>
+          <a:chOff x="0" y="0"/>
+          <a:chExt cx="0" cy="0"/>
+        </a:xfrm>
+      </p:grpSpPr>
       <p:sp>
         <p:nvSpPr>
           <p:cNvPr id="2" name="Rectangle 1"/>
@@ -13588,6 +14103,7 @@
           <a:lstStyle/>
           <a:p>
             <a:pPr algn="ctr"/>
+            <a:endParaRPr/>
           </a:p>
         </p:txBody>
       </p:sp>
@@ -13748,7 +14264,7 @@
 </file>
 
 <file path=ppt/slides/slide8.xml><?xml version="1.0" encoding="utf-8"?>
-<p:sld xmlns:a="http://schemas.openxmlformats.org/drawingml/2006/main" xmlns:p="http://schemas.openxmlformats.org/presentationml/2006/main" xmlns:r="http://schemas.openxmlformats.org/officeDocument/2006/relationships">
+<p:sld xmlns:a="http://schemas.openxmlformats.org/drawingml/2006/main" xmlns:r="http://schemas.openxmlformats.org/officeDocument/2006/relationships" xmlns:p="http://schemas.openxmlformats.org/presentationml/2006/main">
   <p:cSld>
     <p:bg>
       <p:bgPr>
@@ -13764,7 +14280,14 @@
         <p:cNvGrpSpPr/>
         <p:nvPr/>
       </p:nvGrpSpPr>
-      <p:grpSpPr/>
+      <p:grpSpPr>
+        <a:xfrm>
+          <a:off x="0" y="0"/>
+          <a:ext cx="0" cy="0"/>
+          <a:chOff x="0" y="0"/>
+          <a:chExt cx="0" cy="0"/>
+        </a:xfrm>
+      </p:grpSpPr>
       <p:sp>
         <p:nvSpPr>
           <p:cNvPr id="2" name="Rectangle 1"/>
@@ -13805,6 +14328,7 @@
           <a:lstStyle/>
           <a:p>
             <a:pPr algn="ctr"/>
+            <a:endParaRPr/>
           </a:p>
         </p:txBody>
       </p:sp>
@@ -13980,7 +14504,7 @@
 </file>
 
 <file path=ppt/slides/slide9.xml><?xml version="1.0" encoding="utf-8"?>
-<p:sld xmlns:a="http://schemas.openxmlformats.org/drawingml/2006/main" xmlns:p="http://schemas.openxmlformats.org/presentationml/2006/main" xmlns:r="http://schemas.openxmlformats.org/officeDocument/2006/relationships">
+<p:sld xmlns:a="http://schemas.openxmlformats.org/drawingml/2006/main" xmlns:r="http://schemas.openxmlformats.org/officeDocument/2006/relationships" xmlns:p="http://schemas.openxmlformats.org/presentationml/2006/main">
   <p:cSld>
     <p:bg>
       <p:bgPr>
@@ -13996,7 +14520,14 @@
         <p:cNvGrpSpPr/>
         <p:nvPr/>
       </p:nvGrpSpPr>
-      <p:grpSpPr/>
+      <p:grpSpPr>
+        <a:xfrm>
+          <a:off x="0" y="0"/>
+          <a:ext cx="0" cy="0"/>
+          <a:chOff x="0" y="0"/>
+          <a:chExt cx="0" cy="0"/>
+        </a:xfrm>
+      </p:grpSpPr>
       <p:sp>
         <p:nvSpPr>
           <p:cNvPr id="2" name="Rectangle 1"/>
@@ -14037,6 +14568,7 @@
           <a:lstStyle/>
           <a:p>
             <a:pPr algn="ctr"/>
+            <a:endParaRPr/>
           </a:p>
         </p:txBody>
       </p:sp>

</xml_diff>